<commit_message>
feat(lms): estilo sobrio con más contraste, letra más grande y diapositivas a pantalla completa
- Fondo grafito con retícula fina y un morado profundo; las letras J M D son estrellas de
  cuatro puntas (sin lotos ni pétalos). Botones en oro, texto secundario más claro, base 17 px
  y contenedor más ancho para que las diapositivas se lean mejor.
- Visor con botón de pantalla completa.
- PPT de la clase 1 regenerada en el mismo estilo, con texto blanco y cuerpos de 16-17 pt.

Co-Authored-By: Claude Opus 5.5 <noreply@anthropic.com>
</commit_message>
<xml_diff>
--- a/lms/content/courses/programacion-agentica/materials/clase-01-diapositivas.pptx
+++ b/lms/content/courses/programacion-agentica/materials/clase-01-diapositivas.pptx
@@ -125,13 +125,13 @@
   <p:extLst>
     <p:ext uri="{521415D9-36F7-43E2-AB2F-B90AF26B5E84}">
       <p14:sectionLst xmlns:p14="http://schemas.microsoft.com/office/powerpoint/2010/main">
-        <p14:section name="Apertura" id="{f8856e99-2780-7b4e-c3b8-fc3cb0620085}">
+        <p14:section name="Apertura" id="{2d77594b-4346-8ead-d13a-5f2bfc6bd638}">
           <p14:sldIdLst>
             <p14:sldId id="256"/>
             <p14:sldId id="257"/>
           </p14:sldIdLst>
         </p14:section>
-        <p14:section name="Instalación" id="{6b6a9737-7598-6169-20f4-e6c7765765bb}">
+        <p14:section name="Instalación" id="{4d182a36-d537-be12-09c4-24026e3e1106}">
           <p14:sldIdLst>
             <p14:sldId id="258"/>
             <p14:sldId id="259"/>
@@ -140,7 +140,7 @@
             <p14:sldId id="262"/>
           </p14:sldIdLst>
         </p14:section>
-        <p14:section name="Conceptos" id="{af298220-540d-3df5-57a2-4afebae04214}">
+        <p14:section name="Conceptos" id="{7f124423-bf08-2c3d-f94e-a801c7c39ba1}">
           <p14:sldIdLst>
             <p14:sldId id="263"/>
             <p14:sldId id="264"/>
@@ -149,20 +149,20 @@
             <p14:sldId id="267"/>
           </p14:sldIdLst>
         </p14:section>
-        <p14:section name="Ahorro de tokens" id="{75c32764-a27f-d62f-0aa9-21cd4642997e}">
+        <p14:section name="Ahorro de tokens" id="{2bf8d332-3e8d-02e5-338d-9e02f04885f9}">
           <p14:sldIdLst>
             <p14:sldId id="268"/>
             <p14:sldId id="269"/>
           </p14:sldIdLst>
         </p14:section>
-        <p14:section name="MCP y skills" id="{af984246-1157-ca8c-2888-f2a36cabc3e8}">
+        <p14:section name="MCP y skills" id="{432b5f62-c6dc-880b-a06f-b822ce5e3d7c}">
           <p14:sldIdLst>
             <p14:sldId id="270"/>
             <p14:sldId id="271"/>
             <p14:sldId id="272"/>
           </p14:sldIdLst>
         </p14:section>
-        <p14:section name="Cierre" id="{fabe9cf4-6cfc-51c2-e959-1876ba6f5239}">
+        <p14:section name="Cierre" id="{bb9b0532-b81a-ea1b-7702-6fc825554822}">
           <p14:sldIdLst>
             <p14:sldId id="273"/>
             <p14:sldId id="274"/>
@@ -3204,14 +3204,14 @@
               <a:buNone/>
             </a:pPr>
             <a:r>
-              <a:rPr lang="en-US" sz="1800" i="1" dirty="0">
+              <a:rPr lang="en-US" sz="2000" i="1" dirty="0">
                 <a:solidFill>
                   <a:schemeClr val="accent1"/>
                 </a:solidFill>
               </a:rPr>
               <a:t>Quien aloja el modelo y te da una API para llamarlo, con su URL, su clave, su cuota y su precio</a:t>
             </a:r>
-            <a:endParaRPr lang="en-US" sz="1800" dirty="0"/>
+            <a:endParaRPr lang="en-US" sz="2000" dirty="0"/>
           </a:p>
         </p:txBody>
       </p:sp>
@@ -3774,14 +3774,14 @@
               <a:buNone/>
             </a:pPr>
             <a:r>
-              <a:rPr lang="en-US" sz="1500" dirty="0">
+              <a:rPr lang="en-US" sz="1600" dirty="0">
                 <a:solidFill>
                   <a:schemeClr val="bg2"/>
                 </a:solidFill>
               </a:rPr>
               <a:t>En el gateway, un proveedor son tres líneas:</a:t>
             </a:r>
-            <a:endParaRPr lang="en-US" sz="1500" dirty="0"/>
+            <a:endParaRPr lang="en-US" sz="1600" dirty="0"/>
           </a:p>
         </p:txBody>
       </p:sp>
@@ -3923,14 +3923,14 @@
             </a:avLst>
           </a:prstGeom>
           <a:solidFill>
-            <a:schemeClr val="accent4">
-              <a:alpha val="28000"/>
+            <a:schemeClr val="tx2">
+              <a:alpha val="88000"/>
             </a:schemeClr>
           </a:solidFill>
           <a:ln w="9525">
             <a:solidFill>
               <a:schemeClr val="accent1">
-                <a:alpha val="45000"/>
+                <a:alpha val="35000"/>
               </a:schemeClr>
             </a:solidFill>
             <a:prstDash val="solid"/>
@@ -4015,14 +4015,14 @@
               <a:buNone/>
             </a:pPr>
             <a:r>
-              <a:rPr lang="en-US" sz="1800" b="1" dirty="0">
+              <a:rPr lang="en-US" sz="2000" b="1" dirty="0">
                 <a:solidFill>
                   <a:schemeClr val="bg1"/>
                 </a:solidFill>
               </a:rPr>
               <a:t>OpenRouter: un agregador</a:t>
             </a:r>
-            <a:endParaRPr lang="en-US" sz="1800" dirty="0"/>
+            <a:endParaRPr lang="en-US" sz="2000" dirty="0"/>
           </a:p>
         </p:txBody>
       </p:sp>
@@ -4054,14 +4054,14 @@
               <a:buNone/>
             </a:pPr>
             <a:r>
-              <a:rPr lang="en-US" sz="1400" dirty="0">
+              <a:rPr lang="en-US" sz="1700" dirty="0">
                 <a:solidFill>
                   <a:schemeClr val="bg2"/>
                 </a:solidFill>
               </a:rPr>
               <a:t>Cientos de modelos de muchos laboratorios con una sola clave y una capa gratuita (:free) que usaremos mucho.</a:t>
             </a:r>
-            <a:endParaRPr lang="en-US" sz="1400" dirty="0"/>
+            <a:endParaRPr lang="en-US" sz="1700" dirty="0"/>
           </a:p>
         </p:txBody>
       </p:sp>
@@ -4198,14 +4198,14 @@
               <a:buNone/>
             </a:pPr>
             <a:r>
-              <a:rPr lang="en-US" sz="1800" i="1" dirty="0">
+              <a:rPr lang="en-US" sz="2000" i="1" dirty="0">
                 <a:solidFill>
                   <a:schemeClr val="accent1"/>
                 </a:solidFill>
               </a:rPr>
               <a:t>La red neuronal entrenada que produce el texto: gemini-2.5-flash, claude-sonnet, nemotron…</a:t>
             </a:r>
-            <a:endParaRPr lang="en-US" sz="1800" dirty="0"/>
+            <a:endParaRPr lang="en-US" sz="2000" dirty="0"/>
           </a:p>
         </p:txBody>
       </p:sp>
@@ -4226,14 +4226,14 @@
             </a:avLst>
           </a:prstGeom>
           <a:solidFill>
-            <a:schemeClr val="accent4">
-              <a:alpha val="28000"/>
+            <a:schemeClr val="tx2">
+              <a:alpha val="88000"/>
             </a:schemeClr>
           </a:solidFill>
           <a:ln w="9525">
             <a:solidFill>
               <a:schemeClr val="accent1">
-                <a:alpha val="45000"/>
+                <a:alpha val="35000"/>
               </a:schemeClr>
             </a:solidFill>
             <a:prstDash val="solid"/>
@@ -4354,14 +4354,14 @@
               <a:buNone/>
             </a:pPr>
             <a:r>
-              <a:rPr lang="en-US" sz="1400" dirty="0">
+              <a:rPr lang="en-US" sz="1600" dirty="0">
                 <a:solidFill>
                   <a:schemeClr val="bg2"/>
                 </a:solidFill>
               </a:rPr>
               <a:t>Texto, código, razonamiento, tools, JSON, imagen, audio, PDF</a:t>
             </a:r>
-            <a:endParaRPr lang="en-US" sz="1400" dirty="0"/>
+            <a:endParaRPr lang="en-US" sz="1600" dirty="0"/>
           </a:p>
         </p:txBody>
       </p:sp>
@@ -4382,14 +4382,14 @@
             </a:avLst>
           </a:prstGeom>
           <a:solidFill>
-            <a:schemeClr val="accent4">
-              <a:alpha val="28000"/>
+            <a:schemeClr val="tx2">
+              <a:alpha val="88000"/>
             </a:schemeClr>
           </a:solidFill>
           <a:ln w="9525">
             <a:solidFill>
               <a:schemeClr val="accent1">
-                <a:alpha val="45000"/>
+                <a:alpha val="35000"/>
               </a:schemeClr>
             </a:solidFill>
             <a:prstDash val="solid"/>
@@ -4510,14 +4510,14 @@
               <a:buNone/>
             </a:pPr>
             <a:r>
-              <a:rPr lang="en-US" sz="1400" dirty="0">
+              <a:rPr lang="en-US" sz="1600" dirty="0">
                 <a:solidFill>
                   <a:schemeClr val="bg2"/>
                 </a:solidFill>
               </a:rPr>
               <a:t>Cuántos tokens caben: 128 k, 1 M…</a:t>
             </a:r>
-            <a:endParaRPr lang="en-US" sz="1400" dirty="0"/>
+            <a:endParaRPr lang="en-US" sz="1600" dirty="0"/>
           </a:p>
         </p:txBody>
       </p:sp>
@@ -4538,14 +4538,14 @@
             </a:avLst>
           </a:prstGeom>
           <a:solidFill>
-            <a:schemeClr val="accent4">
-              <a:alpha val="28000"/>
+            <a:schemeClr val="tx2">
+              <a:alpha val="88000"/>
             </a:schemeClr>
           </a:solidFill>
           <a:ln w="9525">
             <a:solidFill>
               <a:schemeClr val="accent1">
-                <a:alpha val="45000"/>
+                <a:alpha val="35000"/>
               </a:schemeClr>
             </a:solidFill>
             <a:prstDash val="solid"/>
@@ -4666,14 +4666,14 @@
               <a:buNone/>
             </a:pPr>
             <a:r>
-              <a:rPr lang="en-US" sz="1400" dirty="0">
+              <a:rPr lang="en-US" sz="1600" dirty="0">
                 <a:solidFill>
                   <a:schemeClr val="bg2"/>
                 </a:solidFill>
               </a:rPr>
               <a:t>Por millón de tokens; los :free cuestan 0 con cuota</a:t>
             </a:r>
-            <a:endParaRPr lang="en-US" sz="1400" dirty="0"/>
+            <a:endParaRPr lang="en-US" sz="1600" dirty="0"/>
           </a:p>
         </p:txBody>
       </p:sp>
@@ -4694,14 +4694,14 @@
             </a:avLst>
           </a:prstGeom>
           <a:solidFill>
-            <a:schemeClr val="accent4">
-              <a:alpha val="28000"/>
+            <a:schemeClr val="tx2">
+              <a:alpha val="88000"/>
             </a:schemeClr>
           </a:solidFill>
           <a:ln w="9525">
             <a:solidFill>
               <a:schemeClr val="accent1">
-                <a:alpha val="45000"/>
+                <a:alpha val="35000"/>
               </a:schemeClr>
             </a:solidFill>
             <a:prstDash val="solid"/>
@@ -4822,14 +4822,14 @@
               <a:buNone/>
             </a:pPr>
             <a:r>
-              <a:rPr lang="en-US" sz="1400" dirty="0">
+              <a:rPr lang="en-US" sz="1600" dirty="0">
                 <a:solidFill>
                   <a:schemeClr val="bg2"/>
                 </a:solidFill>
               </a:rPr>
               <a:t>Tokens por segundo y latencia al primer token</a:t>
             </a:r>
-            <a:endParaRPr lang="en-US" sz="1400" dirty="0"/>
+            <a:endParaRPr lang="en-US" sz="1600" dirty="0"/>
           </a:p>
         </p:txBody>
       </p:sp>
@@ -4850,14 +4850,14 @@
             </a:avLst>
           </a:prstGeom>
           <a:solidFill>
-            <a:schemeClr val="accent4">
-              <a:alpha val="28000"/>
+            <a:schemeClr val="tx2">
+              <a:alpha val="88000"/>
             </a:schemeClr>
           </a:solidFill>
           <a:ln w="9525">
             <a:solidFill>
               <a:schemeClr val="accent1">
-                <a:alpha val="45000"/>
+                <a:alpha val="35000"/>
               </a:schemeClr>
             </a:solidFill>
             <a:prstDash val="solid"/>
@@ -4978,14 +4978,14 @@
               <a:buNone/>
             </a:pPr>
             <a:r>
-              <a:rPr lang="en-US" sz="1400" dirty="0">
+              <a:rPr lang="en-US" sz="1600" dirty="0">
                 <a:solidFill>
                   <a:schemeClr val="bg2"/>
                 </a:solidFill>
               </a:rPr>
               <a:t>Benchmarks y, sobre todo, tu telemetría</a:t>
             </a:r>
-            <a:endParaRPr lang="en-US" sz="1400" dirty="0"/>
+            <a:endParaRPr lang="en-US" sz="1600" dirty="0"/>
           </a:p>
         </p:txBody>
       </p:sp>
@@ -5006,14 +5006,14 @@
             </a:avLst>
           </a:prstGeom>
           <a:solidFill>
-            <a:schemeClr val="accent4">
-              <a:alpha val="28000"/>
+            <a:schemeClr val="tx2">
+              <a:alpha val="88000"/>
             </a:schemeClr>
           </a:solidFill>
           <a:ln w="9525">
             <a:solidFill>
               <a:schemeClr val="accent1">
-                <a:alpha val="45000"/>
+                <a:alpha val="35000"/>
               </a:schemeClr>
             </a:solidFill>
             <a:prstDash val="solid"/>
@@ -5200,14 +5200,14 @@
               <a:buNone/>
             </a:pPr>
             <a:r>
-              <a:rPr lang="en-US" sz="1800" i="1" dirty="0">
+              <a:rPr lang="en-US" sz="2000" i="1" dirty="0">
                 <a:solidFill>
                   <a:schemeClr val="accent1"/>
                 </a:solidFill>
               </a:rPr>
               <a:t>Van en cada petición y cambian cómo responde el mismo modelo</a:t>
             </a:r>
-            <a:endParaRPr lang="en-US" sz="1800" dirty="0"/>
+            <a:endParaRPr lang="en-US" sz="2000" dirty="0"/>
           </a:p>
         </p:txBody>
       </p:sp>
@@ -5234,11 +5234,11 @@
             <a:tbl>
               <a:tblPr/>
               <a:tblGrid>
-                <a:gridCol w="2011680"/>
-                <a:gridCol w="3200400"/>
+                <a:gridCol w="2103120"/>
+                <a:gridCol w="3108960"/>
                 <a:gridCol w="1737360"/>
               </a:tblGrid>
-              <a:tr h="502920">
+              <a:tr h="566928">
                 <a:tc>
                   <a:txBody>
                     <a:bodyPr/>
@@ -5248,20 +5248,20 @@
                         <a:buNone/>
                       </a:pPr>
                       <a:r>
-                        <a:rPr lang="en-US" sz="1400" b="1" dirty="0">
+                        <a:rPr lang="en-US" sz="1600" b="1" dirty="0">
                           <a:solidFill>
-                            <a:srgbClr val="16052E"/>
+                            <a:srgbClr val="0B0A10"/>
                           </a:solidFill>
                         </a:rPr>
                         <a:t>Parámetro</a:t>
                       </a:r>
-                      <a:endParaRPr lang="en-US" sz="1400" dirty="0"/>
+                      <a:endParaRPr lang="en-US" sz="1600" dirty="0"/>
                     </a:p>
                   </a:txBody>
                   <a:tcPr marL="91440" marR="91440" marT="45720" marB="45720" anchor="ctr">
                     <a:lnL w="6350" cap="flat" cmpd="sng" algn="ctr">
                       <a:solidFill>
-                        <a:srgbClr val="5B3E99"/>
+                        <a:srgbClr val="4A4470"/>
                       </a:solidFill>
                       <a:prstDash val="solid"/>
                       <a:round/>
@@ -5270,7 +5270,7 @@
                     </a:lnL>
                     <a:lnR w="6350" cap="flat" cmpd="sng" algn="ctr">
                       <a:solidFill>
-                        <a:srgbClr val="5B3E99"/>
+                        <a:srgbClr val="4A4470"/>
                       </a:solidFill>
                       <a:prstDash val="solid"/>
                       <a:round/>
@@ -5279,7 +5279,7 @@
                     </a:lnR>
                     <a:lnT w="6350" cap="flat" cmpd="sng" algn="ctr">
                       <a:solidFill>
-                        <a:srgbClr val="5B3E99"/>
+                        <a:srgbClr val="4A4470"/>
                       </a:solidFill>
                       <a:prstDash val="solid"/>
                       <a:round/>
@@ -5288,7 +5288,7 @@
                     </a:lnT>
                     <a:lnB w="6350" cap="flat" cmpd="sng" algn="ctr">
                       <a:solidFill>
-                        <a:srgbClr val="5B3E99"/>
+                        <a:srgbClr val="4A4470"/>
                       </a:solidFill>
                       <a:prstDash val="solid"/>
                       <a:round/>
@@ -5296,7 +5296,7 @@
                       <a:tailEnd type="none" w="med" len="med"/>
                     </a:lnB>
                     <a:solidFill>
-                      <a:srgbClr val="F2C14E"/>
+                      <a:srgbClr val="E2B84A"/>
                     </a:solidFill>
                   </a:tcPr>
                 </a:tc>
@@ -5309,20 +5309,20 @@
                         <a:buNone/>
                       </a:pPr>
                       <a:r>
-                        <a:rPr lang="en-US" sz="1400" b="1" dirty="0">
+                        <a:rPr lang="en-US" sz="1600" b="1" dirty="0">
                           <a:solidFill>
-                            <a:srgbClr val="16052E"/>
+                            <a:srgbClr val="0B0A10"/>
                           </a:solidFill>
                         </a:rPr>
                         <a:t>Qué hace</a:t>
                       </a:r>
-                      <a:endParaRPr lang="en-US" sz="1400" dirty="0"/>
+                      <a:endParaRPr lang="en-US" sz="1600" dirty="0"/>
                     </a:p>
                   </a:txBody>
                   <a:tcPr marL="91440" marR="91440" marT="45720" marB="45720" anchor="ctr">
                     <a:lnL w="6350" cap="flat" cmpd="sng" algn="ctr">
                       <a:solidFill>
-                        <a:srgbClr val="5B3E99"/>
+                        <a:srgbClr val="4A4470"/>
                       </a:solidFill>
                       <a:prstDash val="solid"/>
                       <a:round/>
@@ -5331,7 +5331,7 @@
                     </a:lnL>
                     <a:lnR w="6350" cap="flat" cmpd="sng" algn="ctr">
                       <a:solidFill>
-                        <a:srgbClr val="5B3E99"/>
+                        <a:srgbClr val="4A4470"/>
                       </a:solidFill>
                       <a:prstDash val="solid"/>
                       <a:round/>
@@ -5340,7 +5340,7 @@
                     </a:lnR>
                     <a:lnT w="6350" cap="flat" cmpd="sng" algn="ctr">
                       <a:solidFill>
-                        <a:srgbClr val="5B3E99"/>
+                        <a:srgbClr val="4A4470"/>
                       </a:solidFill>
                       <a:prstDash val="solid"/>
                       <a:round/>
@@ -5349,7 +5349,7 @@
                     </a:lnT>
                     <a:lnB w="6350" cap="flat" cmpd="sng" algn="ctr">
                       <a:solidFill>
-                        <a:srgbClr val="5B3E99"/>
+                        <a:srgbClr val="4A4470"/>
                       </a:solidFill>
                       <a:prstDash val="solid"/>
                       <a:round/>
@@ -5357,7 +5357,7 @@
                       <a:tailEnd type="none" w="med" len="med"/>
                     </a:lnB>
                     <a:solidFill>
-                      <a:srgbClr val="F2C14E"/>
+                      <a:srgbClr val="E2B84A"/>
                     </a:solidFill>
                   </a:tcPr>
                 </a:tc>
@@ -5370,20 +5370,20 @@
                         <a:buNone/>
                       </a:pPr>
                       <a:r>
-                        <a:rPr lang="en-US" sz="1400" b="1" dirty="0">
+                        <a:rPr lang="en-US" sz="1600" b="1" dirty="0">
                           <a:solidFill>
-                            <a:srgbClr val="16052E"/>
+                            <a:srgbClr val="0B0A10"/>
                           </a:solidFill>
                         </a:rPr>
                         <a:t>Cuándo</a:t>
                       </a:r>
-                      <a:endParaRPr lang="en-US" sz="1400" dirty="0"/>
+                      <a:endParaRPr lang="en-US" sz="1600" dirty="0"/>
                     </a:p>
                   </a:txBody>
                   <a:tcPr marL="91440" marR="91440" marT="45720" marB="45720" anchor="ctr">
                     <a:lnL w="6350" cap="flat" cmpd="sng" algn="ctr">
                       <a:solidFill>
-                        <a:srgbClr val="5B3E99"/>
+                        <a:srgbClr val="4A4470"/>
                       </a:solidFill>
                       <a:prstDash val="solid"/>
                       <a:round/>
@@ -5392,7 +5392,7 @@
                     </a:lnL>
                     <a:lnR w="6350" cap="flat" cmpd="sng" algn="ctr">
                       <a:solidFill>
-                        <a:srgbClr val="5B3E99"/>
+                        <a:srgbClr val="4A4470"/>
                       </a:solidFill>
                       <a:prstDash val="solid"/>
                       <a:round/>
@@ -5401,7 +5401,7 @@
                     </a:lnR>
                     <a:lnT w="6350" cap="flat" cmpd="sng" algn="ctr">
                       <a:solidFill>
-                        <a:srgbClr val="5B3E99"/>
+                        <a:srgbClr val="4A4470"/>
                       </a:solidFill>
                       <a:prstDash val="solid"/>
                       <a:round/>
@@ -5410,7 +5410,7 @@
                     </a:lnT>
                     <a:lnB w="6350" cap="flat" cmpd="sng" algn="ctr">
                       <a:solidFill>
-                        <a:srgbClr val="5B3E99"/>
+                        <a:srgbClr val="4A4470"/>
                       </a:solidFill>
                       <a:prstDash val="solid"/>
                       <a:round/>
@@ -5418,12 +5418,12 @@
                       <a:tailEnd type="none" w="med" len="med"/>
                     </a:lnB>
                     <a:solidFill>
-                      <a:srgbClr val="F2C14E"/>
+                      <a:srgbClr val="E2B84A"/>
                     </a:solidFill>
                   </a:tcPr>
                 </a:tc>
               </a:tr>
-              <a:tr h="502920">
+              <a:tr h="566928">
                 <a:tc>
                   <a:txBody>
                     <a:bodyPr/>
@@ -5433,9 +5433,9 @@
                         <a:buNone/>
                       </a:pPr>
                       <a:r>
-                        <a:rPr lang="en-US" sz="1400" b="1" dirty="0">
+                        <a:rPr lang="en-US" sz="1600" b="1" dirty="0">
                           <a:solidFill>
-                            <a:srgbClr val="C7B2FF"/>
+                            <a:srgbClr val="C9C1F0"/>
                           </a:solidFill>
                           <a:latin typeface="Courier New" pitchFamily="34" charset="0"/>
                           <a:ea typeface="Courier New" pitchFamily="34" charset="-122"/>
@@ -5443,7 +5443,7 @@
                         </a:rPr>
                         <a:t>temperature</a:t>
                       </a:r>
-                      <a:endParaRPr lang="en-US" sz="1400" dirty="0">
+                      <a:endParaRPr lang="en-US" sz="1600" dirty="0">
                         <a:latin typeface="Courier New" charset="0"/>
                         <a:ea typeface="Courier New" charset="0"/>
                         <a:cs typeface="Courier New" charset="0"/>
@@ -5453,7 +5453,7 @@
                   <a:tcPr marL="91440" marR="91440" marT="45720" marB="45720" anchor="ctr">
                     <a:lnL w="6350" cap="flat" cmpd="sng" algn="ctr">
                       <a:solidFill>
-                        <a:srgbClr val="5B3E99"/>
+                        <a:srgbClr val="4A4470"/>
                       </a:solidFill>
                       <a:prstDash val="solid"/>
                       <a:round/>
@@ -5462,7 +5462,7 @@
                     </a:lnL>
                     <a:lnR w="6350" cap="flat" cmpd="sng" algn="ctr">
                       <a:solidFill>
-                        <a:srgbClr val="5B3E99"/>
+                        <a:srgbClr val="4A4470"/>
                       </a:solidFill>
                       <a:prstDash val="solid"/>
                       <a:round/>
@@ -5471,7 +5471,7 @@
                     </a:lnR>
                     <a:lnT w="6350" cap="flat" cmpd="sng" algn="ctr">
                       <a:solidFill>
-                        <a:srgbClr val="5B3E99"/>
+                        <a:srgbClr val="4A4470"/>
                       </a:solidFill>
                       <a:prstDash val="solid"/>
                       <a:round/>
@@ -5480,7 +5480,7 @@
                     </a:lnT>
                     <a:lnB w="6350" cap="flat" cmpd="sng" algn="ctr">
                       <a:solidFill>
-                        <a:srgbClr val="5B3E99"/>
+                        <a:srgbClr val="4A4470"/>
                       </a:solidFill>
                       <a:prstDash val="solid"/>
                       <a:round/>
@@ -5488,7 +5488,7 @@
                       <a:tailEnd type="none" w="med" len="med"/>
                     </a:lnB>
                     <a:solidFill>
-                      <a:srgbClr val="2E0D5E"/>
+                      <a:srgbClr val="1C1830"/>
                     </a:solidFill>
                   </a:tcPr>
                 </a:tc>
@@ -5501,20 +5501,20 @@
                         <a:buNone/>
                       </a:pPr>
                       <a:r>
-                        <a:rPr lang="en-US" sz="1400" dirty="0">
+                        <a:rPr lang="en-US" sz="1600" dirty="0">
                           <a:solidFill>
-                            <a:srgbClr val="F7F2FF"/>
+                            <a:srgbClr val="FFFFFF"/>
                           </a:solidFill>
                         </a:rPr>
                         <a:t>Aleatoriedad: 0 casi fijo, 1 creativo</a:t>
                       </a:r>
-                      <a:endParaRPr lang="en-US" sz="1400" dirty="0"/>
+                      <a:endParaRPr lang="en-US" sz="1600" dirty="0"/>
                     </a:p>
                   </a:txBody>
                   <a:tcPr marL="91440" marR="91440" marT="45720" marB="45720" anchor="ctr">
                     <a:lnL w="6350" cap="flat" cmpd="sng" algn="ctr">
                       <a:solidFill>
-                        <a:srgbClr val="5B3E99"/>
+                        <a:srgbClr val="4A4470"/>
                       </a:solidFill>
                       <a:prstDash val="solid"/>
                       <a:round/>
@@ -5523,7 +5523,7 @@
                     </a:lnL>
                     <a:lnR w="6350" cap="flat" cmpd="sng" algn="ctr">
                       <a:solidFill>
-                        <a:srgbClr val="5B3E99"/>
+                        <a:srgbClr val="4A4470"/>
                       </a:solidFill>
                       <a:prstDash val="solid"/>
                       <a:round/>
@@ -5532,7 +5532,7 @@
                     </a:lnR>
                     <a:lnT w="6350" cap="flat" cmpd="sng" algn="ctr">
                       <a:solidFill>
-                        <a:srgbClr val="5B3E99"/>
+                        <a:srgbClr val="4A4470"/>
                       </a:solidFill>
                       <a:prstDash val="solid"/>
                       <a:round/>
@@ -5541,7 +5541,7 @@
                     </a:lnT>
                     <a:lnB w="6350" cap="flat" cmpd="sng" algn="ctr">
                       <a:solidFill>
-                        <a:srgbClr val="5B3E99"/>
+                        <a:srgbClr val="4A4470"/>
                       </a:solidFill>
                       <a:prstDash val="solid"/>
                       <a:round/>
@@ -5549,7 +5549,7 @@
                       <a:tailEnd type="none" w="med" len="med"/>
                     </a:lnB>
                     <a:solidFill>
-                      <a:srgbClr val="2E0D5E"/>
+                      <a:srgbClr val="1C1830"/>
                     </a:solidFill>
                   </a:tcPr>
                 </a:tc>
@@ -5562,20 +5562,20 @@
                         <a:buNone/>
                       </a:pPr>
                       <a:r>
-                        <a:rPr lang="en-US" sz="1400" dirty="0">
+                        <a:rPr lang="en-US" sz="1600" dirty="0">
                           <a:solidFill>
-                            <a:srgbClr val="F7F2FF"/>
+                            <a:srgbClr val="FFFFFF"/>
                           </a:solidFill>
                         </a:rPr>
                         <a:t>Código: 0.1–0.3</a:t>
                       </a:r>
-                      <a:endParaRPr lang="en-US" sz="1400" dirty="0"/>
+                      <a:endParaRPr lang="en-US" sz="1600" dirty="0"/>
                     </a:p>
                   </a:txBody>
                   <a:tcPr marL="91440" marR="91440" marT="45720" marB="45720" anchor="ctr">
                     <a:lnL w="6350" cap="flat" cmpd="sng" algn="ctr">
                       <a:solidFill>
-                        <a:srgbClr val="5B3E99"/>
+                        <a:srgbClr val="4A4470"/>
                       </a:solidFill>
                       <a:prstDash val="solid"/>
                       <a:round/>
@@ -5584,7 +5584,7 @@
                     </a:lnL>
                     <a:lnR w="6350" cap="flat" cmpd="sng" algn="ctr">
                       <a:solidFill>
-                        <a:srgbClr val="5B3E99"/>
+                        <a:srgbClr val="4A4470"/>
                       </a:solidFill>
                       <a:prstDash val="solid"/>
                       <a:round/>
@@ -5593,7 +5593,7 @@
                     </a:lnR>
                     <a:lnT w="6350" cap="flat" cmpd="sng" algn="ctr">
                       <a:solidFill>
-                        <a:srgbClr val="5B3E99"/>
+                        <a:srgbClr val="4A4470"/>
                       </a:solidFill>
                       <a:prstDash val="solid"/>
                       <a:round/>
@@ -5602,7 +5602,7 @@
                     </a:lnT>
                     <a:lnB w="6350" cap="flat" cmpd="sng" algn="ctr">
                       <a:solidFill>
-                        <a:srgbClr val="5B3E99"/>
+                        <a:srgbClr val="4A4470"/>
                       </a:solidFill>
                       <a:prstDash val="solid"/>
                       <a:round/>
@@ -5610,12 +5610,12 @@
                       <a:tailEnd type="none" w="med" len="med"/>
                     </a:lnB>
                     <a:solidFill>
-                      <a:srgbClr val="2E0D5E"/>
+                      <a:srgbClr val="1C1830"/>
                     </a:solidFill>
                   </a:tcPr>
                 </a:tc>
               </a:tr>
-              <a:tr h="502920">
+              <a:tr h="566928">
                 <a:tc>
                   <a:txBody>
                     <a:bodyPr/>
@@ -5625,9 +5625,9 @@
                         <a:buNone/>
                       </a:pPr>
                       <a:r>
-                        <a:rPr lang="en-US" sz="1400" b="1" dirty="0">
+                        <a:rPr lang="en-US" sz="1600" b="1" dirty="0">
                           <a:solidFill>
-                            <a:srgbClr val="C7B2FF"/>
+                            <a:srgbClr val="C9C1F0"/>
                           </a:solidFill>
                           <a:latin typeface="Courier New" pitchFamily="34" charset="0"/>
                           <a:ea typeface="Courier New" pitchFamily="34" charset="-122"/>
@@ -5635,7 +5635,7 @@
                         </a:rPr>
                         <a:t>top_p</a:t>
                       </a:r>
-                      <a:endParaRPr lang="en-US" sz="1400" dirty="0">
+                      <a:endParaRPr lang="en-US" sz="1600" dirty="0">
                         <a:latin typeface="Courier New" charset="0"/>
                         <a:ea typeface="Courier New" charset="0"/>
                         <a:cs typeface="Courier New" charset="0"/>
@@ -5645,7 +5645,7 @@
                   <a:tcPr marL="91440" marR="91440" marT="45720" marB="45720" anchor="ctr">
                     <a:lnL w="6350" cap="flat" cmpd="sng" algn="ctr">
                       <a:solidFill>
-                        <a:srgbClr val="5B3E99"/>
+                        <a:srgbClr val="4A4470"/>
                       </a:solidFill>
                       <a:prstDash val="solid"/>
                       <a:round/>
@@ -5654,7 +5654,7 @@
                     </a:lnL>
                     <a:lnR w="6350" cap="flat" cmpd="sng" algn="ctr">
                       <a:solidFill>
-                        <a:srgbClr val="5B3E99"/>
+                        <a:srgbClr val="4A4470"/>
                       </a:solidFill>
                       <a:prstDash val="solid"/>
                       <a:round/>
@@ -5663,7 +5663,7 @@
                     </a:lnR>
                     <a:lnT w="6350" cap="flat" cmpd="sng" algn="ctr">
                       <a:solidFill>
-                        <a:srgbClr val="5B3E99"/>
+                        <a:srgbClr val="4A4470"/>
                       </a:solidFill>
                       <a:prstDash val="solid"/>
                       <a:round/>
@@ -5672,7 +5672,7 @@
                     </a:lnT>
                     <a:lnB w="6350" cap="flat" cmpd="sng" algn="ctr">
                       <a:solidFill>
-                        <a:srgbClr val="5B3E99"/>
+                        <a:srgbClr val="4A4470"/>
                       </a:solidFill>
                       <a:prstDash val="solid"/>
                       <a:round/>
@@ -5680,7 +5680,7 @@
                       <a:tailEnd type="none" w="med" len="med"/>
                     </a:lnB>
                     <a:solidFill>
-                      <a:srgbClr val="2E0D5E"/>
+                      <a:srgbClr val="1C1830"/>
                     </a:solidFill>
                   </a:tcPr>
                 </a:tc>
@@ -5693,20 +5693,20 @@
                         <a:buNone/>
                       </a:pPr>
                       <a:r>
-                        <a:rPr lang="en-US" sz="1400" dirty="0">
+                        <a:rPr lang="en-US" sz="1600" dirty="0">
                           <a:solidFill>
-                            <a:srgbClr val="F7F2FF"/>
+                            <a:srgbClr val="FFFFFF"/>
                           </a:solidFill>
                         </a:rPr>
                         <a:t>Solo los tokens que suman esa probabilidad</a:t>
                       </a:r>
-                      <a:endParaRPr lang="en-US" sz="1400" dirty="0"/>
+                      <a:endParaRPr lang="en-US" sz="1600" dirty="0"/>
                     </a:p>
                   </a:txBody>
                   <a:tcPr marL="91440" marR="91440" marT="45720" marB="45720" anchor="ctr">
                     <a:lnL w="6350" cap="flat" cmpd="sng" algn="ctr">
                       <a:solidFill>
-                        <a:srgbClr val="5B3E99"/>
+                        <a:srgbClr val="4A4470"/>
                       </a:solidFill>
                       <a:prstDash val="solid"/>
                       <a:round/>
@@ -5715,7 +5715,7 @@
                     </a:lnL>
                     <a:lnR w="6350" cap="flat" cmpd="sng" algn="ctr">
                       <a:solidFill>
-                        <a:srgbClr val="5B3E99"/>
+                        <a:srgbClr val="4A4470"/>
                       </a:solidFill>
                       <a:prstDash val="solid"/>
                       <a:round/>
@@ -5724,7 +5724,7 @@
                     </a:lnR>
                     <a:lnT w="6350" cap="flat" cmpd="sng" algn="ctr">
                       <a:solidFill>
-                        <a:srgbClr val="5B3E99"/>
+                        <a:srgbClr val="4A4470"/>
                       </a:solidFill>
                       <a:prstDash val="solid"/>
                       <a:round/>
@@ -5733,7 +5733,7 @@
                     </a:lnT>
                     <a:lnB w="6350" cap="flat" cmpd="sng" algn="ctr">
                       <a:solidFill>
-                        <a:srgbClr val="5B3E99"/>
+                        <a:srgbClr val="4A4470"/>
                       </a:solidFill>
                       <a:prstDash val="solid"/>
                       <a:round/>
@@ -5741,7 +5741,7 @@
                       <a:tailEnd type="none" w="med" len="med"/>
                     </a:lnB>
                     <a:solidFill>
-                      <a:srgbClr val="2E0D5E"/>
+                      <a:srgbClr val="1C1830"/>
                     </a:solidFill>
                   </a:tcPr>
                 </a:tc>
@@ -5754,20 +5754,20 @@
                         <a:buNone/>
                       </a:pPr>
                       <a:r>
-                        <a:rPr lang="en-US" sz="1400" dirty="0">
+                        <a:rPr lang="en-US" sz="1600" dirty="0">
                           <a:solidFill>
-                            <a:srgbClr val="F7F2FF"/>
+                            <a:srgbClr val="FFFFFF"/>
                           </a:solidFill>
                         </a:rPr>
                         <a:t>No subas los dos</a:t>
                       </a:r>
-                      <a:endParaRPr lang="en-US" sz="1400" dirty="0"/>
+                      <a:endParaRPr lang="en-US" sz="1600" dirty="0"/>
                     </a:p>
                   </a:txBody>
                   <a:tcPr marL="91440" marR="91440" marT="45720" marB="45720" anchor="ctr">
                     <a:lnL w="6350" cap="flat" cmpd="sng" algn="ctr">
                       <a:solidFill>
-                        <a:srgbClr val="5B3E99"/>
+                        <a:srgbClr val="4A4470"/>
                       </a:solidFill>
                       <a:prstDash val="solid"/>
                       <a:round/>
@@ -5776,7 +5776,7 @@
                     </a:lnL>
                     <a:lnR w="6350" cap="flat" cmpd="sng" algn="ctr">
                       <a:solidFill>
-                        <a:srgbClr val="5B3E99"/>
+                        <a:srgbClr val="4A4470"/>
                       </a:solidFill>
                       <a:prstDash val="solid"/>
                       <a:round/>
@@ -5785,7 +5785,7 @@
                     </a:lnR>
                     <a:lnT w="6350" cap="flat" cmpd="sng" algn="ctr">
                       <a:solidFill>
-                        <a:srgbClr val="5B3E99"/>
+                        <a:srgbClr val="4A4470"/>
                       </a:solidFill>
                       <a:prstDash val="solid"/>
                       <a:round/>
@@ -5794,7 +5794,7 @@
                     </a:lnT>
                     <a:lnB w="6350" cap="flat" cmpd="sng" algn="ctr">
                       <a:solidFill>
-                        <a:srgbClr val="5B3E99"/>
+                        <a:srgbClr val="4A4470"/>
                       </a:solidFill>
                       <a:prstDash val="solid"/>
                       <a:round/>
@@ -5802,12 +5802,12 @@
                       <a:tailEnd type="none" w="med" len="med"/>
                     </a:lnB>
                     <a:solidFill>
-                      <a:srgbClr val="2E0D5E"/>
+                      <a:srgbClr val="1C1830"/>
                     </a:solidFill>
                   </a:tcPr>
                 </a:tc>
               </a:tr>
-              <a:tr h="502920">
+              <a:tr h="566928">
                 <a:tc>
                   <a:txBody>
                     <a:bodyPr/>
@@ -5817,9 +5817,9 @@
                         <a:buNone/>
                       </a:pPr>
                       <a:r>
-                        <a:rPr lang="en-US" sz="1400" b="1" dirty="0">
+                        <a:rPr lang="en-US" sz="1600" b="1" dirty="0">
                           <a:solidFill>
-                            <a:srgbClr val="C7B2FF"/>
+                            <a:srgbClr val="C9C1F0"/>
                           </a:solidFill>
                           <a:latin typeface="Courier New" pitchFamily="34" charset="0"/>
                           <a:ea typeface="Courier New" pitchFamily="34" charset="-122"/>
@@ -5827,7 +5827,7 @@
                         </a:rPr>
                         <a:t>max_tokens</a:t>
                       </a:r>
-                      <a:endParaRPr lang="en-US" sz="1400" dirty="0">
+                      <a:endParaRPr lang="en-US" sz="1600" dirty="0">
                         <a:latin typeface="Courier New" charset="0"/>
                         <a:ea typeface="Courier New" charset="0"/>
                         <a:cs typeface="Courier New" charset="0"/>
@@ -5837,7 +5837,7 @@
                   <a:tcPr marL="91440" marR="91440" marT="45720" marB="45720" anchor="ctr">
                     <a:lnL w="6350" cap="flat" cmpd="sng" algn="ctr">
                       <a:solidFill>
-                        <a:srgbClr val="5B3E99"/>
+                        <a:srgbClr val="4A4470"/>
                       </a:solidFill>
                       <a:prstDash val="solid"/>
                       <a:round/>
@@ -5846,7 +5846,7 @@
                     </a:lnL>
                     <a:lnR w="6350" cap="flat" cmpd="sng" algn="ctr">
                       <a:solidFill>
-                        <a:srgbClr val="5B3E99"/>
+                        <a:srgbClr val="4A4470"/>
                       </a:solidFill>
                       <a:prstDash val="solid"/>
                       <a:round/>
@@ -5855,7 +5855,7 @@
                     </a:lnR>
                     <a:lnT w="6350" cap="flat" cmpd="sng" algn="ctr">
                       <a:solidFill>
-                        <a:srgbClr val="5B3E99"/>
+                        <a:srgbClr val="4A4470"/>
                       </a:solidFill>
                       <a:prstDash val="solid"/>
                       <a:round/>
@@ -5864,7 +5864,7 @@
                     </a:lnT>
                     <a:lnB w="6350" cap="flat" cmpd="sng" algn="ctr">
                       <a:solidFill>
-                        <a:srgbClr val="5B3E99"/>
+                        <a:srgbClr val="4A4470"/>
                       </a:solidFill>
                       <a:prstDash val="solid"/>
                       <a:round/>
@@ -5872,7 +5872,7 @@
                       <a:tailEnd type="none" w="med" len="med"/>
                     </a:lnB>
                     <a:solidFill>
-                      <a:srgbClr val="2E0D5E"/>
+                      <a:srgbClr val="1C1830"/>
                     </a:solidFill>
                   </a:tcPr>
                 </a:tc>
@@ -5885,20 +5885,20 @@
                         <a:buNone/>
                       </a:pPr>
                       <a:r>
-                        <a:rPr lang="en-US" sz="1400" dirty="0">
+                        <a:rPr lang="en-US" sz="1600" dirty="0">
                           <a:solidFill>
-                            <a:srgbClr val="F7F2FF"/>
+                            <a:srgbClr val="FFFFFF"/>
                           </a:solidFill>
                         </a:rPr>
                         <a:t>Tope de salida</a:t>
                       </a:r>
-                      <a:endParaRPr lang="en-US" sz="1400" dirty="0"/>
+                      <a:endParaRPr lang="en-US" sz="1600" dirty="0"/>
                     </a:p>
                   </a:txBody>
                   <a:tcPr marL="91440" marR="91440" marT="45720" marB="45720" anchor="ctr">
                     <a:lnL w="6350" cap="flat" cmpd="sng" algn="ctr">
                       <a:solidFill>
-                        <a:srgbClr val="5B3E99"/>
+                        <a:srgbClr val="4A4470"/>
                       </a:solidFill>
                       <a:prstDash val="solid"/>
                       <a:round/>
@@ -5907,7 +5907,7 @@
                     </a:lnL>
                     <a:lnR w="6350" cap="flat" cmpd="sng" algn="ctr">
                       <a:solidFill>
-                        <a:srgbClr val="5B3E99"/>
+                        <a:srgbClr val="4A4470"/>
                       </a:solidFill>
                       <a:prstDash val="solid"/>
                       <a:round/>
@@ -5916,7 +5916,7 @@
                     </a:lnR>
                     <a:lnT w="6350" cap="flat" cmpd="sng" algn="ctr">
                       <a:solidFill>
-                        <a:srgbClr val="5B3E99"/>
+                        <a:srgbClr val="4A4470"/>
                       </a:solidFill>
                       <a:prstDash val="solid"/>
                       <a:round/>
@@ -5925,7 +5925,7 @@
                     </a:lnT>
                     <a:lnB w="6350" cap="flat" cmpd="sng" algn="ctr">
                       <a:solidFill>
-                        <a:srgbClr val="5B3E99"/>
+                        <a:srgbClr val="4A4470"/>
                       </a:solidFill>
                       <a:prstDash val="solid"/>
                       <a:round/>
@@ -5933,7 +5933,7 @@
                       <a:tailEnd type="none" w="med" len="med"/>
                     </a:lnB>
                     <a:solidFill>
-                      <a:srgbClr val="2E0D5E"/>
+                      <a:srgbClr val="1C1830"/>
                     </a:solidFill>
                   </a:tcPr>
                 </a:tc>
@@ -5946,20 +5946,20 @@
                         <a:buNone/>
                       </a:pPr>
                       <a:r>
-                        <a:rPr lang="en-US" sz="1400" dirty="0">
+                        <a:rPr lang="en-US" sz="1600" dirty="0">
                           <a:solidFill>
-                            <a:srgbClr val="F7F2FF"/>
+                            <a:srgbClr val="FFFFFF"/>
                           </a:solidFill>
                         </a:rPr>
                         <a:t>Cuida la cuota</a:t>
                       </a:r>
-                      <a:endParaRPr lang="en-US" sz="1400" dirty="0"/>
+                      <a:endParaRPr lang="en-US" sz="1600" dirty="0"/>
                     </a:p>
                   </a:txBody>
                   <a:tcPr marL="91440" marR="91440" marT="45720" marB="45720" anchor="ctr">
                     <a:lnL w="6350" cap="flat" cmpd="sng" algn="ctr">
                       <a:solidFill>
-                        <a:srgbClr val="5B3E99"/>
+                        <a:srgbClr val="4A4470"/>
                       </a:solidFill>
                       <a:prstDash val="solid"/>
                       <a:round/>
@@ -5968,7 +5968,7 @@
                     </a:lnL>
                     <a:lnR w="6350" cap="flat" cmpd="sng" algn="ctr">
                       <a:solidFill>
-                        <a:srgbClr val="5B3E99"/>
+                        <a:srgbClr val="4A4470"/>
                       </a:solidFill>
                       <a:prstDash val="solid"/>
                       <a:round/>
@@ -5977,7 +5977,7 @@
                     </a:lnR>
                     <a:lnT w="6350" cap="flat" cmpd="sng" algn="ctr">
                       <a:solidFill>
-                        <a:srgbClr val="5B3E99"/>
+                        <a:srgbClr val="4A4470"/>
                       </a:solidFill>
                       <a:prstDash val="solid"/>
                       <a:round/>
@@ -5986,7 +5986,7 @@
                     </a:lnT>
                     <a:lnB w="6350" cap="flat" cmpd="sng" algn="ctr">
                       <a:solidFill>
-                        <a:srgbClr val="5B3E99"/>
+                        <a:srgbClr val="4A4470"/>
                       </a:solidFill>
                       <a:prstDash val="solid"/>
                       <a:round/>
@@ -5994,12 +5994,12 @@
                       <a:tailEnd type="none" w="med" len="med"/>
                     </a:lnB>
                     <a:solidFill>
-                      <a:srgbClr val="2E0D5E"/>
+                      <a:srgbClr val="1C1830"/>
                     </a:solidFill>
                   </a:tcPr>
                 </a:tc>
               </a:tr>
-              <a:tr h="502920">
+              <a:tr h="566928">
                 <a:tc>
                   <a:txBody>
                     <a:bodyPr/>
@@ -6009,9 +6009,9 @@
                         <a:buNone/>
                       </a:pPr>
                       <a:r>
-                        <a:rPr lang="en-US" sz="1400" b="1" dirty="0">
+                        <a:rPr lang="en-US" sz="1600" b="1" dirty="0">
                           <a:solidFill>
-                            <a:srgbClr val="C7B2FF"/>
+                            <a:srgbClr val="C9C1F0"/>
                           </a:solidFill>
                           <a:latin typeface="Courier New" pitchFamily="34" charset="0"/>
                           <a:ea typeface="Courier New" pitchFamily="34" charset="-122"/>
@@ -6019,7 +6019,7 @@
                         </a:rPr>
                         <a:t>system</a:t>
                       </a:r>
-                      <a:endParaRPr lang="en-US" sz="1400" dirty="0">
+                      <a:endParaRPr lang="en-US" sz="1600" dirty="0">
                         <a:latin typeface="Courier New" charset="0"/>
                         <a:ea typeface="Courier New" charset="0"/>
                         <a:cs typeface="Courier New" charset="0"/>
@@ -6029,7 +6029,7 @@
                   <a:tcPr marL="91440" marR="91440" marT="45720" marB="45720" anchor="ctr">
                     <a:lnL w="6350" cap="flat" cmpd="sng" algn="ctr">
                       <a:solidFill>
-                        <a:srgbClr val="5B3E99"/>
+                        <a:srgbClr val="4A4470"/>
                       </a:solidFill>
                       <a:prstDash val="solid"/>
                       <a:round/>
@@ -6038,7 +6038,7 @@
                     </a:lnL>
                     <a:lnR w="6350" cap="flat" cmpd="sng" algn="ctr">
                       <a:solidFill>
-                        <a:srgbClr val="5B3E99"/>
+                        <a:srgbClr val="4A4470"/>
                       </a:solidFill>
                       <a:prstDash val="solid"/>
                       <a:round/>
@@ -6047,7 +6047,7 @@
                     </a:lnR>
                     <a:lnT w="6350" cap="flat" cmpd="sng" algn="ctr">
                       <a:solidFill>
-                        <a:srgbClr val="5B3E99"/>
+                        <a:srgbClr val="4A4470"/>
                       </a:solidFill>
                       <a:prstDash val="solid"/>
                       <a:round/>
@@ -6056,7 +6056,7 @@
                     </a:lnT>
                     <a:lnB w="6350" cap="flat" cmpd="sng" algn="ctr">
                       <a:solidFill>
-                        <a:srgbClr val="5B3E99"/>
+                        <a:srgbClr val="4A4470"/>
                       </a:solidFill>
                       <a:prstDash val="solid"/>
                       <a:round/>
@@ -6064,7 +6064,7 @@
                       <a:tailEnd type="none" w="med" len="med"/>
                     </a:lnB>
                     <a:solidFill>
-                      <a:srgbClr val="2E0D5E"/>
+                      <a:srgbClr val="1C1830"/>
                     </a:solidFill>
                   </a:tcPr>
                 </a:tc>
@@ -6077,20 +6077,20 @@
                         <a:buNone/>
                       </a:pPr>
                       <a:r>
-                        <a:rPr lang="en-US" sz="1400" dirty="0">
+                        <a:rPr lang="en-US" sz="1600" dirty="0">
                           <a:solidFill>
-                            <a:srgbClr val="F7F2FF"/>
+                            <a:srgbClr val="FFFFFF"/>
                           </a:solidFill>
                         </a:rPr>
                         <a:t>Rol y estilo de toda la conversación</a:t>
                       </a:r>
-                      <a:endParaRPr lang="en-US" sz="1400" dirty="0"/>
+                      <a:endParaRPr lang="en-US" sz="1600" dirty="0"/>
                     </a:p>
                   </a:txBody>
                   <a:tcPr marL="91440" marR="91440" marT="45720" marB="45720" anchor="ctr">
                     <a:lnL w="6350" cap="flat" cmpd="sng" algn="ctr">
                       <a:solidFill>
-                        <a:srgbClr val="5B3E99"/>
+                        <a:srgbClr val="4A4470"/>
                       </a:solidFill>
                       <a:prstDash val="solid"/>
                       <a:round/>
@@ -6099,7 +6099,7 @@
                     </a:lnL>
                     <a:lnR w="6350" cap="flat" cmpd="sng" algn="ctr">
                       <a:solidFill>
-                        <a:srgbClr val="5B3E99"/>
+                        <a:srgbClr val="4A4470"/>
                       </a:solidFill>
                       <a:prstDash val="solid"/>
                       <a:round/>
@@ -6108,7 +6108,7 @@
                     </a:lnR>
                     <a:lnT w="6350" cap="flat" cmpd="sng" algn="ctr">
                       <a:solidFill>
-                        <a:srgbClr val="5B3E99"/>
+                        <a:srgbClr val="4A4470"/>
                       </a:solidFill>
                       <a:prstDash val="solid"/>
                       <a:round/>
@@ -6117,7 +6117,7 @@
                     </a:lnT>
                     <a:lnB w="6350" cap="flat" cmpd="sng" algn="ctr">
                       <a:solidFill>
-                        <a:srgbClr val="5B3E99"/>
+                        <a:srgbClr val="4A4470"/>
                       </a:solidFill>
                       <a:prstDash val="solid"/>
                       <a:round/>
@@ -6125,7 +6125,7 @@
                       <a:tailEnd type="none" w="med" len="med"/>
                     </a:lnB>
                     <a:solidFill>
-                      <a:srgbClr val="2E0D5E"/>
+                      <a:srgbClr val="1C1830"/>
                     </a:solidFill>
                   </a:tcPr>
                 </a:tc>
@@ -6138,20 +6138,20 @@
                         <a:buNone/>
                       </a:pPr>
                       <a:r>
-                        <a:rPr lang="en-US" sz="1400" dirty="0">
+                        <a:rPr lang="en-US" sz="1600" dirty="0">
                           <a:solidFill>
-                            <a:srgbClr val="F7F2FF"/>
+                            <a:srgbClr val="FFFFFF"/>
                           </a:solidFill>
                         </a:rPr>
                         <a:t>Siempre</a:t>
                       </a:r>
-                      <a:endParaRPr lang="en-US" sz="1400" dirty="0"/>
+                      <a:endParaRPr lang="en-US" sz="1600" dirty="0"/>
                     </a:p>
                   </a:txBody>
                   <a:tcPr marL="91440" marR="91440" marT="45720" marB="45720" anchor="ctr">
                     <a:lnL w="6350" cap="flat" cmpd="sng" algn="ctr">
                       <a:solidFill>
-                        <a:srgbClr val="5B3E99"/>
+                        <a:srgbClr val="4A4470"/>
                       </a:solidFill>
                       <a:prstDash val="solid"/>
                       <a:round/>
@@ -6160,7 +6160,7 @@
                     </a:lnL>
                     <a:lnR w="6350" cap="flat" cmpd="sng" algn="ctr">
                       <a:solidFill>
-                        <a:srgbClr val="5B3E99"/>
+                        <a:srgbClr val="4A4470"/>
                       </a:solidFill>
                       <a:prstDash val="solid"/>
                       <a:round/>
@@ -6169,7 +6169,7 @@
                     </a:lnR>
                     <a:lnT w="6350" cap="flat" cmpd="sng" algn="ctr">
                       <a:solidFill>
-                        <a:srgbClr val="5B3E99"/>
+                        <a:srgbClr val="4A4470"/>
                       </a:solidFill>
                       <a:prstDash val="solid"/>
                       <a:round/>
@@ -6178,7 +6178,7 @@
                     </a:lnT>
                     <a:lnB w="6350" cap="flat" cmpd="sng" algn="ctr">
                       <a:solidFill>
-                        <a:srgbClr val="5B3E99"/>
+                        <a:srgbClr val="4A4470"/>
                       </a:solidFill>
                       <a:prstDash val="solid"/>
                       <a:round/>
@@ -6186,12 +6186,12 @@
                       <a:tailEnd type="none" w="med" len="med"/>
                     </a:lnB>
                     <a:solidFill>
-                      <a:srgbClr val="2E0D5E"/>
+                      <a:srgbClr val="1C1830"/>
                     </a:solidFill>
                   </a:tcPr>
                 </a:tc>
               </a:tr>
-              <a:tr h="502920">
+              <a:tr h="566928">
                 <a:tc>
                   <a:txBody>
                     <a:bodyPr/>
@@ -6201,9 +6201,9 @@
                         <a:buNone/>
                       </a:pPr>
                       <a:r>
-                        <a:rPr lang="en-US" sz="1400" b="1" dirty="0">
+                        <a:rPr lang="en-US" sz="1600" b="1" dirty="0">
                           <a:solidFill>
-                            <a:srgbClr val="C7B2FF"/>
+                            <a:srgbClr val="C9C1F0"/>
                           </a:solidFill>
                           <a:latin typeface="Courier New" pitchFamily="34" charset="0"/>
                           <a:ea typeface="Courier New" pitchFamily="34" charset="-122"/>
@@ -6211,7 +6211,7 @@
                         </a:rPr>
                         <a:t>tools</a:t>
                       </a:r>
-                      <a:endParaRPr lang="en-US" sz="1400" dirty="0">
+                      <a:endParaRPr lang="en-US" sz="1600" dirty="0">
                         <a:latin typeface="Courier New" charset="0"/>
                         <a:ea typeface="Courier New" charset="0"/>
                         <a:cs typeface="Courier New" charset="0"/>
@@ -6221,7 +6221,7 @@
                   <a:tcPr marL="91440" marR="91440" marT="45720" marB="45720" anchor="ctr">
                     <a:lnL w="6350" cap="flat" cmpd="sng" algn="ctr">
                       <a:solidFill>
-                        <a:srgbClr val="5B3E99"/>
+                        <a:srgbClr val="4A4470"/>
                       </a:solidFill>
                       <a:prstDash val="solid"/>
                       <a:round/>
@@ -6230,7 +6230,7 @@
                     </a:lnL>
                     <a:lnR w="6350" cap="flat" cmpd="sng" algn="ctr">
                       <a:solidFill>
-                        <a:srgbClr val="5B3E99"/>
+                        <a:srgbClr val="4A4470"/>
                       </a:solidFill>
                       <a:prstDash val="solid"/>
                       <a:round/>
@@ -6239,7 +6239,7 @@
                     </a:lnR>
                     <a:lnT w="6350" cap="flat" cmpd="sng" algn="ctr">
                       <a:solidFill>
-                        <a:srgbClr val="5B3E99"/>
+                        <a:srgbClr val="4A4470"/>
                       </a:solidFill>
                       <a:prstDash val="solid"/>
                       <a:round/>
@@ -6248,7 +6248,7 @@
                     </a:lnT>
                     <a:lnB w="6350" cap="flat" cmpd="sng" algn="ctr">
                       <a:solidFill>
-                        <a:srgbClr val="5B3E99"/>
+                        <a:srgbClr val="4A4470"/>
                       </a:solidFill>
                       <a:prstDash val="solid"/>
                       <a:round/>
@@ -6256,7 +6256,7 @@
                       <a:tailEnd type="none" w="med" len="med"/>
                     </a:lnB>
                     <a:solidFill>
-                      <a:srgbClr val="2E0D5E"/>
+                      <a:srgbClr val="1C1830"/>
                     </a:solidFill>
                   </a:tcPr>
                 </a:tc>
@@ -6269,20 +6269,20 @@
                         <a:buNone/>
                       </a:pPr>
                       <a:r>
-                        <a:rPr lang="en-US" sz="1400" dirty="0">
+                        <a:rPr lang="en-US" sz="1600" dirty="0">
                           <a:solidFill>
-                            <a:srgbClr val="F7F2FF"/>
+                            <a:srgbClr val="FFFFFF"/>
                           </a:solidFill>
                         </a:rPr>
                         <a:t>Funciones que el modelo puede pedir</a:t>
                       </a:r>
-                      <a:endParaRPr lang="en-US" sz="1400" dirty="0"/>
+                      <a:endParaRPr lang="en-US" sz="1600" dirty="0"/>
                     </a:p>
                   </a:txBody>
                   <a:tcPr marL="91440" marR="91440" marT="45720" marB="45720" anchor="ctr">
                     <a:lnL w="6350" cap="flat" cmpd="sng" algn="ctr">
                       <a:solidFill>
-                        <a:srgbClr val="5B3E99"/>
+                        <a:srgbClr val="4A4470"/>
                       </a:solidFill>
                       <a:prstDash val="solid"/>
                       <a:round/>
@@ -6291,7 +6291,7 @@
                     </a:lnL>
                     <a:lnR w="6350" cap="flat" cmpd="sng" algn="ctr">
                       <a:solidFill>
-                        <a:srgbClr val="5B3E99"/>
+                        <a:srgbClr val="4A4470"/>
                       </a:solidFill>
                       <a:prstDash val="solid"/>
                       <a:round/>
@@ -6300,7 +6300,7 @@
                     </a:lnR>
                     <a:lnT w="6350" cap="flat" cmpd="sng" algn="ctr">
                       <a:solidFill>
-                        <a:srgbClr val="5B3E99"/>
+                        <a:srgbClr val="4A4470"/>
                       </a:solidFill>
                       <a:prstDash val="solid"/>
                       <a:round/>
@@ -6309,7 +6309,7 @@
                     </a:lnT>
                     <a:lnB w="6350" cap="flat" cmpd="sng" algn="ctr">
                       <a:solidFill>
-                        <a:srgbClr val="5B3E99"/>
+                        <a:srgbClr val="4A4470"/>
                       </a:solidFill>
                       <a:prstDash val="solid"/>
                       <a:round/>
@@ -6317,7 +6317,7 @@
                       <a:tailEnd type="none" w="med" len="med"/>
                     </a:lnB>
                     <a:solidFill>
-                      <a:srgbClr val="2E0D5E"/>
+                      <a:srgbClr val="1C1830"/>
                     </a:solidFill>
                   </a:tcPr>
                 </a:tc>
@@ -6330,20 +6330,20 @@
                         <a:buNone/>
                       </a:pPr>
                       <a:r>
-                        <a:rPr lang="en-US" sz="1400" dirty="0">
+                        <a:rPr lang="en-US" sz="1600" dirty="0">
                           <a:solidFill>
-                            <a:srgbClr val="F7F2FF"/>
+                            <a:srgbClr val="FFFFFF"/>
                           </a:solidFill>
                         </a:rPr>
                         <a:t>Lo que hace agente</a:t>
                       </a:r>
-                      <a:endParaRPr lang="en-US" sz="1400" dirty="0"/>
+                      <a:endParaRPr lang="en-US" sz="1600" dirty="0"/>
                     </a:p>
                   </a:txBody>
                   <a:tcPr marL="91440" marR="91440" marT="45720" marB="45720" anchor="ctr">
                     <a:lnL w="6350" cap="flat" cmpd="sng" algn="ctr">
                       <a:solidFill>
-                        <a:srgbClr val="5B3E99"/>
+                        <a:srgbClr val="4A4470"/>
                       </a:solidFill>
                       <a:prstDash val="solid"/>
                       <a:round/>
@@ -6352,7 +6352,7 @@
                     </a:lnL>
                     <a:lnR w="6350" cap="flat" cmpd="sng" algn="ctr">
                       <a:solidFill>
-                        <a:srgbClr val="5B3E99"/>
+                        <a:srgbClr val="4A4470"/>
                       </a:solidFill>
                       <a:prstDash val="solid"/>
                       <a:round/>
@@ -6361,7 +6361,7 @@
                     </a:lnR>
                     <a:lnT w="6350" cap="flat" cmpd="sng" algn="ctr">
                       <a:solidFill>
-                        <a:srgbClr val="5B3E99"/>
+                        <a:srgbClr val="4A4470"/>
                       </a:solidFill>
                       <a:prstDash val="solid"/>
                       <a:round/>
@@ -6370,7 +6370,7 @@
                     </a:lnT>
                     <a:lnB w="6350" cap="flat" cmpd="sng" algn="ctr">
                       <a:solidFill>
-                        <a:srgbClr val="5B3E99"/>
+                        <a:srgbClr val="4A4470"/>
                       </a:solidFill>
                       <a:prstDash val="solid"/>
                       <a:round/>
@@ -6378,12 +6378,12 @@
                       <a:tailEnd type="none" w="med" len="med"/>
                     </a:lnB>
                     <a:solidFill>
-                      <a:srgbClr val="2E0D5E"/>
+                      <a:srgbClr val="1C1830"/>
                     </a:solidFill>
                   </a:tcPr>
                 </a:tc>
               </a:tr>
-              <a:tr h="502920">
+              <a:tr h="566928">
                 <a:tc>
                   <a:txBody>
                     <a:bodyPr/>
@@ -6393,9 +6393,9 @@
                         <a:buNone/>
                       </a:pPr>
                       <a:r>
-                        <a:rPr lang="en-US" sz="1400" b="1" dirty="0">
+                        <a:rPr lang="en-US" sz="1600" b="1" dirty="0">
                           <a:solidFill>
-                            <a:srgbClr val="C7B2FF"/>
+                            <a:srgbClr val="C9C1F0"/>
                           </a:solidFill>
                           <a:latin typeface="Courier New" pitchFamily="34" charset="0"/>
                           <a:ea typeface="Courier New" pitchFamily="34" charset="-122"/>
@@ -6403,7 +6403,7 @@
                         </a:rPr>
                         <a:t>response_format</a:t>
                       </a:r>
-                      <a:endParaRPr lang="en-US" sz="1400" dirty="0">
+                      <a:endParaRPr lang="en-US" sz="1600" dirty="0">
                         <a:latin typeface="Courier New" charset="0"/>
                         <a:ea typeface="Courier New" charset="0"/>
                         <a:cs typeface="Courier New" charset="0"/>
@@ -6413,7 +6413,7 @@
                   <a:tcPr marL="91440" marR="91440" marT="45720" marB="45720" anchor="ctr">
                     <a:lnL w="6350" cap="flat" cmpd="sng" algn="ctr">
                       <a:solidFill>
-                        <a:srgbClr val="5B3E99"/>
+                        <a:srgbClr val="4A4470"/>
                       </a:solidFill>
                       <a:prstDash val="solid"/>
                       <a:round/>
@@ -6422,7 +6422,7 @@
                     </a:lnL>
                     <a:lnR w="6350" cap="flat" cmpd="sng" algn="ctr">
                       <a:solidFill>
-                        <a:srgbClr val="5B3E99"/>
+                        <a:srgbClr val="4A4470"/>
                       </a:solidFill>
                       <a:prstDash val="solid"/>
                       <a:round/>
@@ -6431,7 +6431,7 @@
                     </a:lnR>
                     <a:lnT w="6350" cap="flat" cmpd="sng" algn="ctr">
                       <a:solidFill>
-                        <a:srgbClr val="5B3E99"/>
+                        <a:srgbClr val="4A4470"/>
                       </a:solidFill>
                       <a:prstDash val="solid"/>
                       <a:round/>
@@ -6440,7 +6440,7 @@
                     </a:lnT>
                     <a:lnB w="6350" cap="flat" cmpd="sng" algn="ctr">
                       <a:solidFill>
-                        <a:srgbClr val="5B3E99"/>
+                        <a:srgbClr val="4A4470"/>
                       </a:solidFill>
                       <a:prstDash val="solid"/>
                       <a:round/>
@@ -6448,7 +6448,7 @@
                       <a:tailEnd type="none" w="med" len="med"/>
                     </a:lnB>
                     <a:solidFill>
-                      <a:srgbClr val="2E0D5E"/>
+                      <a:srgbClr val="1C1830"/>
                     </a:solidFill>
                   </a:tcPr>
                 </a:tc>
@@ -6461,20 +6461,20 @@
                         <a:buNone/>
                       </a:pPr>
                       <a:r>
-                        <a:rPr lang="en-US" sz="1400" dirty="0">
+                        <a:rPr lang="en-US" sz="1600" dirty="0">
                           <a:solidFill>
-                            <a:srgbClr val="F7F2FF"/>
+                            <a:srgbClr val="FFFFFF"/>
                           </a:solidFill>
                         </a:rPr>
                         <a:t>Forzar JSON o un esquema</a:t>
                       </a:r>
-                      <a:endParaRPr lang="en-US" sz="1400" dirty="0"/>
+                      <a:endParaRPr lang="en-US" sz="1600" dirty="0"/>
                     </a:p>
                   </a:txBody>
                   <a:tcPr marL="91440" marR="91440" marT="45720" marB="45720" anchor="ctr">
                     <a:lnL w="6350" cap="flat" cmpd="sng" algn="ctr">
                       <a:solidFill>
-                        <a:srgbClr val="5B3E99"/>
+                        <a:srgbClr val="4A4470"/>
                       </a:solidFill>
                       <a:prstDash val="solid"/>
                       <a:round/>
@@ -6483,7 +6483,7 @@
                     </a:lnL>
                     <a:lnR w="6350" cap="flat" cmpd="sng" algn="ctr">
                       <a:solidFill>
-                        <a:srgbClr val="5B3E99"/>
+                        <a:srgbClr val="4A4470"/>
                       </a:solidFill>
                       <a:prstDash val="solid"/>
                       <a:round/>
@@ -6492,7 +6492,7 @@
                     </a:lnR>
                     <a:lnT w="6350" cap="flat" cmpd="sng" algn="ctr">
                       <a:solidFill>
-                        <a:srgbClr val="5B3E99"/>
+                        <a:srgbClr val="4A4470"/>
                       </a:solidFill>
                       <a:prstDash val="solid"/>
                       <a:round/>
@@ -6501,7 +6501,7 @@
                     </a:lnT>
                     <a:lnB w="6350" cap="flat" cmpd="sng" algn="ctr">
                       <a:solidFill>
-                        <a:srgbClr val="5B3E99"/>
+                        <a:srgbClr val="4A4470"/>
                       </a:solidFill>
                       <a:prstDash val="solid"/>
                       <a:round/>
@@ -6509,7 +6509,7 @@
                       <a:tailEnd type="none" w="med" len="med"/>
                     </a:lnB>
                     <a:solidFill>
-                      <a:srgbClr val="2E0D5E"/>
+                      <a:srgbClr val="1C1830"/>
                     </a:solidFill>
                   </a:tcPr>
                 </a:tc>
@@ -6522,20 +6522,20 @@
                         <a:buNone/>
                       </a:pPr>
                       <a:r>
-                        <a:rPr lang="en-US" sz="1400" dirty="0">
+                        <a:rPr lang="en-US" sz="1600" dirty="0">
                           <a:solidFill>
-                            <a:srgbClr val="F7F2FF"/>
+                            <a:srgbClr val="FFFFFF"/>
                           </a:solidFill>
                         </a:rPr>
                         <a:t>Si lo lee un programa</a:t>
                       </a:r>
-                      <a:endParaRPr lang="en-US" sz="1400" dirty="0"/>
+                      <a:endParaRPr lang="en-US" sz="1600" dirty="0"/>
                     </a:p>
                   </a:txBody>
                   <a:tcPr marL="91440" marR="91440" marT="45720" marB="45720" anchor="ctr">
                     <a:lnL w="6350" cap="flat" cmpd="sng" algn="ctr">
                       <a:solidFill>
-                        <a:srgbClr val="5B3E99"/>
+                        <a:srgbClr val="4A4470"/>
                       </a:solidFill>
                       <a:prstDash val="solid"/>
                       <a:round/>
@@ -6544,7 +6544,7 @@
                     </a:lnL>
                     <a:lnR w="6350" cap="flat" cmpd="sng" algn="ctr">
                       <a:solidFill>
-                        <a:srgbClr val="5B3E99"/>
+                        <a:srgbClr val="4A4470"/>
                       </a:solidFill>
                       <a:prstDash val="solid"/>
                       <a:round/>
@@ -6553,7 +6553,7 @@
                     </a:lnR>
                     <a:lnT w="6350" cap="flat" cmpd="sng" algn="ctr">
                       <a:solidFill>
-                        <a:srgbClr val="5B3E99"/>
+                        <a:srgbClr val="4A4470"/>
                       </a:solidFill>
                       <a:prstDash val="solid"/>
                       <a:round/>
@@ -6562,7 +6562,7 @@
                     </a:lnT>
                     <a:lnB w="6350" cap="flat" cmpd="sng" algn="ctr">
                       <a:solidFill>
-                        <a:srgbClr val="5B3E99"/>
+                        <a:srgbClr val="4A4470"/>
                       </a:solidFill>
                       <a:prstDash val="solid"/>
                       <a:round/>
@@ -6570,7 +6570,7 @@
                       <a:tailEnd type="none" w="med" len="med"/>
                     </a:lnB>
                     <a:solidFill>
-                      <a:srgbClr val="2E0D5E"/>
+                      <a:srgbClr val="1C1830"/>
                     </a:solidFill>
                   </a:tcPr>
                 </a:tc>
@@ -6596,14 +6596,14 @@
             </a:avLst>
           </a:prstGeom>
           <a:solidFill>
-            <a:schemeClr val="accent4">
-              <a:alpha val="28000"/>
+            <a:schemeClr val="tx2">
+              <a:alpha val="88000"/>
             </a:schemeClr>
           </a:solidFill>
           <a:ln w="9525">
             <a:solidFill>
               <a:schemeClr val="accent1">
-                <a:alpha val="45000"/>
+                <a:alpha val="35000"/>
               </a:schemeClr>
             </a:solidFill>
             <a:prstDash val="solid"/>
@@ -6688,14 +6688,14 @@
               <a:buNone/>
             </a:pPr>
             <a:r>
-              <a:rPr lang="en-US" sz="1800" b="1" dirty="0">
+              <a:rPr lang="en-US" sz="2000" b="1" dirty="0">
                 <a:solidFill>
                   <a:schemeClr val="bg1"/>
                 </a:solidFill>
               </a:rPr>
               <a:t>No confundir</a:t>
             </a:r>
-            <a:endParaRPr lang="en-US" sz="1800" dirty="0"/>
+            <a:endParaRPr lang="en-US" sz="2000" dirty="0"/>
           </a:p>
         </p:txBody>
       </p:sp>
@@ -6727,14 +6727,14 @@
               <a:buNone/>
             </a:pPr>
             <a:r>
-              <a:rPr lang="en-US" sz="1400" dirty="0">
+              <a:rPr lang="en-US" sz="1700" dirty="0">
                 <a:solidFill>
                   <a:schemeClr val="bg2"/>
                 </a:solidFill>
               </a:rPr>
               <a:t>Parámetros de generación: van en la petición («baja la temperatura»).</a:t>
             </a:r>
-            <a:endParaRPr lang="en-US" sz="1400" dirty="0"/>
+            <a:endParaRPr lang="en-US" sz="1700" dirty="0"/>
           </a:p>
           <a:p>
             <a:pPr indent="0" marL="0">
@@ -6743,7 +6743,7 @@
               </a:spcAft>
               <a:buNone/>
             </a:pPr>
-            <a:endParaRPr lang="en-US" sz="1400" dirty="0"/>
+            <a:endParaRPr lang="en-US" sz="1700" dirty="0"/>
           </a:p>
           <a:p>
             <a:pPr indent="0" marL="0">
@@ -6753,14 +6753,14 @@
               <a:buNone/>
             </a:pPr>
             <a:r>
-              <a:rPr lang="en-US" sz="1400" dirty="0">
+              <a:rPr lang="en-US" sz="1700" dirty="0">
                 <a:solidFill>
                   <a:schemeClr val="bg2"/>
                 </a:solidFill>
               </a:rPr>
               <a:t>Parámetros del modelo: los pesos que se ajustaron al entrenarlo. «Un modelo de 70 B» tiene 70 000 millones.</a:t>
             </a:r>
-            <a:endParaRPr lang="en-US" sz="1400" dirty="0"/>
+            <a:endParaRPr lang="en-US" sz="1700" dirty="0"/>
           </a:p>
         </p:txBody>
       </p:sp>
@@ -6897,14 +6897,14 @@
               <a:buNone/>
             </a:pPr>
             <a:r>
-              <a:rPr lang="en-US" sz="1800" i="1" dirty="0">
+              <a:rPr lang="en-US" sz="2000" i="1" dirty="0">
                 <a:solidFill>
                   <a:schemeClr val="accent1"/>
                 </a:solidFill>
               </a:rPr>
               <a:t>Rust Token Killer: recorta lo que le ENTRA al modelo</a:t>
             </a:r>
-            <a:endParaRPr lang="en-US" sz="1800" dirty="0"/>
+            <a:endParaRPr lang="en-US" sz="2000" dirty="0"/>
           </a:p>
         </p:txBody>
       </p:sp>
@@ -7211,14 +7211,14 @@
             </a:avLst>
           </a:prstGeom>
           <a:solidFill>
-            <a:schemeClr val="accent4">
-              <a:alpha val="28000"/>
+            <a:schemeClr val="tx2">
+              <a:alpha val="88000"/>
             </a:schemeClr>
           </a:solidFill>
           <a:ln w="9525">
             <a:solidFill>
               <a:schemeClr val="accent1">
-                <a:alpha val="45000"/>
+                <a:alpha val="35000"/>
               </a:schemeClr>
             </a:solidFill>
             <a:prstDash val="solid"/>
@@ -7303,14 +7303,14 @@
               <a:buNone/>
             </a:pPr>
             <a:r>
-              <a:rPr lang="en-US" sz="1800" b="1" dirty="0">
+              <a:rPr lang="en-US" sz="2000" b="1" dirty="0">
                 <a:solidFill>
                   <a:schemeClr val="bg1"/>
                 </a:solidFill>
               </a:rPr>
               <a:t>También en el gateway</a:t>
             </a:r>
-            <a:endParaRPr lang="en-US" sz="1800" dirty="0"/>
+            <a:endParaRPr lang="en-US" sz="2000" dirty="0"/>
           </a:p>
         </p:txBody>
       </p:sp>
@@ -7342,14 +7342,14 @@
               <a:buNone/>
             </a:pPr>
             <a:r>
-              <a:rPr lang="en-US" sz="1400" dirty="0">
+              <a:rPr lang="en-US" sz="1700" dirty="0">
                 <a:solidFill>
                   <a:schemeClr val="bg2"/>
                 </a:solidFill>
               </a:rPr>
               <a:t>savings.compress_tool_output hace lo mismo para clientes sin hooks.</a:t>
             </a:r>
-            <a:endParaRPr lang="en-US" sz="1400" dirty="0"/>
+            <a:endParaRPr lang="en-US" sz="1700" dirty="0"/>
           </a:p>
         </p:txBody>
       </p:sp>
@@ -7486,14 +7486,14 @@
               <a:buNone/>
             </a:pPr>
             <a:r>
-              <a:rPr lang="en-US" sz="1800" i="1" dirty="0">
+              <a:rPr lang="en-US" sz="2000" i="1" dirty="0">
                 <a:solidFill>
                   <a:schemeClr val="accent1"/>
                 </a:solidFill>
               </a:rPr>
               <a:t>Plugin de Claude Code que recorta lo que SALE del modelo</a:t>
             </a:r>
-            <a:endParaRPr lang="en-US" sz="1800" dirty="0"/>
+            <a:endParaRPr lang="en-US" sz="2000" dirty="0"/>
           </a:p>
         </p:txBody>
       </p:sp>
@@ -7514,14 +7514,14 @@
             </a:avLst>
           </a:prstGeom>
           <a:solidFill>
-            <a:schemeClr val="accent4">
-              <a:alpha val="28000"/>
+            <a:schemeClr val="tx2">
+              <a:alpha val="88000"/>
             </a:schemeClr>
           </a:solidFill>
           <a:ln w="9525">
             <a:solidFill>
               <a:schemeClr val="accent1">
-                <a:alpha val="45000"/>
+                <a:alpha val="35000"/>
               </a:schemeClr>
             </a:solidFill>
             <a:prstDash val="solid"/>
@@ -7617,14 +7617,14 @@
             </a:avLst>
           </a:prstGeom>
           <a:solidFill>
-            <a:schemeClr val="accent4">
-              <a:alpha val="28000"/>
+            <a:schemeClr val="tx2">
+              <a:alpha val="88000"/>
             </a:schemeClr>
           </a:solidFill>
           <a:ln w="9525">
             <a:solidFill>
               <a:schemeClr val="accent1">
-                <a:alpha val="45000"/>
+                <a:alpha val="35000"/>
               </a:schemeClr>
             </a:solidFill>
             <a:prstDash val="solid"/>
@@ -7807,14 +7807,14 @@
             </a:avLst>
           </a:prstGeom>
           <a:solidFill>
-            <a:schemeClr val="accent4">
-              <a:alpha val="28000"/>
+            <a:schemeClr val="tx2">
+              <a:alpha val="88000"/>
             </a:schemeClr>
           </a:solidFill>
           <a:ln w="9525">
             <a:solidFill>
               <a:schemeClr val="accent1">
-                <a:alpha val="45000"/>
+                <a:alpha val="35000"/>
               </a:schemeClr>
             </a:solidFill>
             <a:prstDash val="solid"/>
@@ -7899,14 +7899,14 @@
               <a:buNone/>
             </a:pPr>
             <a:r>
-              <a:rPr lang="en-US" sz="1800" b="1" dirty="0">
+              <a:rPr lang="en-US" sz="2000" b="1" dirty="0">
                 <a:solidFill>
                   <a:schemeClr val="bg1"/>
                 </a:solidFill>
               </a:rPr>
               <a:t>Uno solo, no los dos</a:t>
             </a:r>
-            <a:endParaRPr lang="en-US" sz="1800" dirty="0"/>
+            <a:endParaRPr lang="en-US" sz="2000" dirty="0"/>
           </a:p>
         </p:txBody>
       </p:sp>
@@ -7938,14 +7938,14 @@
               <a:buNone/>
             </a:pPr>
             <a:r>
-              <a:rPr lang="en-US" sz="1400" dirty="0">
+              <a:rPr lang="en-US" sz="1700" dirty="0">
                 <a:solidFill>
                   <a:schemeClr val="bg2"/>
                 </a:solidFill>
               </a:rPr>
               <a:t>Si tienes el plugin y el estilo del gateway, el recorte se aplica dos veces. jmd status te avisa.</a:t>
             </a:r>
-            <a:endParaRPr lang="en-US" sz="1400" dirty="0"/>
+            <a:endParaRPr lang="en-US" sz="1700" dirty="0"/>
           </a:p>
         </p:txBody>
       </p:sp>
@@ -8082,14 +8082,14 @@
               <a:buNone/>
             </a:pPr>
             <a:r>
-              <a:rPr lang="en-US" sz="1800" i="1" dirty="0">
+              <a:rPr lang="en-US" sz="2000" i="1" dirty="0">
                 <a:solidFill>
                   <a:schemeClr val="accent1"/>
                 </a:solidFill>
               </a:rPr>
               <a:t>Model Context Protocol: un estándar abierto para conectar agentes con herramientas y datos</a:t>
             </a:r>
-            <a:endParaRPr lang="en-US" sz="1800" dirty="0"/>
+            <a:endParaRPr lang="en-US" sz="2000" dirty="0"/>
           </a:p>
         </p:txBody>
       </p:sp>
@@ -8207,14 +8207,14 @@
               <a:buNone/>
             </a:pPr>
             <a:r>
-              <a:rPr lang="en-US" sz="1200" dirty="0">
+              <a:rPr lang="en-US" sz="1400" dirty="0">
                 <a:solidFill>
                   <a:schemeClr val="bg2"/>
                 </a:solidFill>
               </a:rPr>
               <a:t>Claude Code, OpenCode, Cursor</a:t>
             </a:r>
-            <a:endParaRPr lang="en-US" sz="1200" dirty="0"/>
+            <a:endParaRPr lang="en-US" sz="1400" dirty="0"/>
           </a:p>
         </p:txBody>
       </p:sp>
@@ -8268,28 +8268,28 @@
               <a:buNone/>
             </a:pPr>
             <a:r>
-              <a:rPr lang="en-US" sz="1200" dirty="0">
+              <a:rPr lang="en-US" sz="1400" dirty="0">
                 <a:solidFill>
                   <a:schemeClr val="accent1"/>
                 </a:solidFill>
               </a:rPr>
               <a:t>JSON-RPC</a:t>
             </a:r>
-            <a:endParaRPr lang="en-US" sz="1200" dirty="0"/>
+            <a:endParaRPr lang="en-US" sz="1400" dirty="0"/>
           </a:p>
           <a:p>
             <a:pPr algn="ctr" indent="0" marL="0">
               <a:buNone/>
             </a:pPr>
             <a:r>
-              <a:rPr lang="en-US" sz="1200" dirty="0">
+              <a:rPr lang="en-US" sz="1400" dirty="0">
                 <a:solidFill>
                   <a:schemeClr val="accent1"/>
                 </a:solidFill>
               </a:rPr>
               <a:t>stdio o HTTP</a:t>
             </a:r>
-            <a:endParaRPr lang="en-US" sz="1200" dirty="0"/>
+            <a:endParaRPr lang="en-US" sz="1400" dirty="0"/>
           </a:p>
         </p:txBody>
       </p:sp>
@@ -8407,14 +8407,14 @@
               <a:buNone/>
             </a:pPr>
             <a:r>
-              <a:rPr lang="en-US" sz="1200" dirty="0">
+              <a:rPr lang="en-US" sz="1400" dirty="0">
                 <a:solidFill>
                   <a:schemeClr val="bg2"/>
                 </a:solidFill>
               </a:rPr>
               <a:t>GitHub, base de datos, el LMS</a:t>
             </a:r>
-            <a:endParaRPr lang="en-US" sz="1200" dirty="0"/>
+            <a:endParaRPr lang="en-US" sz="1400" dirty="0"/>
           </a:p>
         </p:txBody>
       </p:sp>
@@ -8435,14 +8435,14 @@
             </a:avLst>
           </a:prstGeom>
           <a:solidFill>
-            <a:schemeClr val="accent4">
-              <a:alpha val="28000"/>
+            <a:schemeClr val="tx2">
+              <a:alpha val="88000"/>
             </a:schemeClr>
           </a:solidFill>
           <a:ln w="9525">
             <a:solidFill>
               <a:schemeClr val="accent1">
-                <a:alpha val="45000"/>
+                <a:alpha val="35000"/>
               </a:schemeClr>
             </a:solidFill>
             <a:prstDash val="solid"/>
@@ -8513,14 +8513,14 @@
             </a:avLst>
           </a:prstGeom>
           <a:solidFill>
-            <a:schemeClr val="accent4">
-              <a:alpha val="28000"/>
+            <a:schemeClr val="tx2">
+              <a:alpha val="88000"/>
             </a:schemeClr>
           </a:solidFill>
           <a:ln w="9525">
             <a:solidFill>
               <a:schemeClr val="accent1">
-                <a:alpha val="45000"/>
+                <a:alpha val="35000"/>
               </a:schemeClr>
             </a:solidFill>
             <a:prstDash val="solid"/>
@@ -8591,14 +8591,14 @@
             </a:avLst>
           </a:prstGeom>
           <a:solidFill>
-            <a:schemeClr val="accent4">
-              <a:alpha val="28000"/>
+            <a:schemeClr val="tx2">
+              <a:alpha val="88000"/>
             </a:schemeClr>
           </a:solidFill>
           <a:ln w="9525">
             <a:solidFill>
               <a:schemeClr val="accent1">
-                <a:alpha val="45000"/>
+                <a:alpha val="35000"/>
               </a:schemeClr>
             </a:solidFill>
             <a:prstDash val="solid"/>
@@ -8872,14 +8872,14 @@
               <a:buNone/>
             </a:pPr>
             <a:r>
-              <a:rPr lang="en-US" sz="1800" i="1" dirty="0">
+              <a:rPr lang="en-US" sz="2000" i="1" dirty="0">
                 <a:solidFill>
                   <a:schemeClr val="accent1"/>
                 </a:solidFill>
               </a:rPr>
               <a:t>Una carpeta con un SKILL.md que enseña al agente a hacer algo concreto</a:t>
             </a:r>
-            <a:endParaRPr lang="en-US" sz="1800" dirty="0"/>
+            <a:endParaRPr lang="en-US" sz="2000" dirty="0"/>
           </a:p>
         </p:txBody>
       </p:sp>
@@ -9029,7 +9029,7 @@
               <a:buNone/>
             </a:pPr>
             <a:r>
-              <a:rPr lang="en-US" sz="1400" b="1" dirty="0">
+              <a:rPr lang="en-US" sz="1600" b="1" dirty="0">
                 <a:solidFill>
                   <a:schemeClr val="accent2"/>
                 </a:solidFill>
@@ -9040,7 +9040,7 @@
               <a:buNone/>
             </a:pPr>
             <a:r>
-              <a:rPr lang="en-US" sz="1400" dirty="0">
+              <a:rPr lang="en-US" sz="1600" dirty="0">
                 <a:solidFill>
                   <a:schemeClr val="bg1"/>
                 </a:solidFill>
@@ -9050,7 +9050,7 @@
               </a:rPr>
               <a:t>.claude/skills/&lt;nombre&gt;/</a:t>
             </a:r>
-            <a:endParaRPr lang="en-US" sz="1400" dirty="0"/>
+            <a:endParaRPr lang="en-US" sz="1600" dirty="0"/>
           </a:p>
         </p:txBody>
       </p:sp>
@@ -9079,7 +9079,7 @@
               <a:buNone/>
             </a:pPr>
             <a:r>
-              <a:rPr lang="en-US" sz="1400" b="1" dirty="0">
+              <a:rPr lang="en-US" sz="1600" b="1" dirty="0">
                 <a:solidFill>
                   <a:schemeClr val="accent2"/>
                 </a:solidFill>
@@ -9090,7 +9090,7 @@
               <a:buNone/>
             </a:pPr>
             <a:r>
-              <a:rPr lang="en-US" sz="1400" dirty="0">
+              <a:rPr lang="en-US" sz="1600" dirty="0">
                 <a:solidFill>
                   <a:schemeClr val="bg1"/>
                 </a:solidFill>
@@ -9100,7 +9100,7 @@
               </a:rPr>
               <a:t>~/.claude/skills/&lt;nombre&gt;/</a:t>
             </a:r>
-            <a:endParaRPr lang="en-US" sz="1400" dirty="0"/>
+            <a:endParaRPr lang="en-US" sz="1600" dirty="0"/>
           </a:p>
         </p:txBody>
       </p:sp>
@@ -9129,7 +9129,7 @@
               <a:buNone/>
             </a:pPr>
             <a:r>
-              <a:rPr lang="en-US" sz="1400" b="1" dirty="0">
+              <a:rPr lang="en-US" sz="1600" b="1" dirty="0">
                 <a:solidFill>
                   <a:schemeClr val="accent2"/>
                 </a:solidFill>
@@ -9140,7 +9140,7 @@
               <a:buNone/>
             </a:pPr>
             <a:r>
-              <a:rPr lang="en-US" sz="1400" dirty="0">
+              <a:rPr lang="en-US" sz="1600" dirty="0">
                 <a:solidFill>
                   <a:schemeClr val="bg1"/>
                 </a:solidFill>
@@ -9150,7 +9150,7 @@
               </a:rPr>
               <a:t>Trae varias skills juntas</a:t>
             </a:r>
-            <a:endParaRPr lang="en-US" sz="1400" dirty="0"/>
+            <a:endParaRPr lang="en-US" sz="1600" dirty="0"/>
           </a:p>
         </p:txBody>
       </p:sp>
@@ -9171,14 +9171,14 @@
             </a:avLst>
           </a:prstGeom>
           <a:solidFill>
-            <a:schemeClr val="accent4">
-              <a:alpha val="28000"/>
+            <a:schemeClr val="tx2">
+              <a:alpha val="88000"/>
             </a:schemeClr>
           </a:solidFill>
           <a:ln w="9525">
             <a:solidFill>
               <a:schemeClr val="accent1">
-                <a:alpha val="45000"/>
+                <a:alpha val="35000"/>
               </a:schemeClr>
             </a:solidFill>
             <a:prstDash val="solid"/>
@@ -9263,14 +9263,14 @@
               <a:buNone/>
             </a:pPr>
             <a:r>
-              <a:rPr lang="en-US" sz="1800" b="1" dirty="0">
+              <a:rPr lang="en-US" sz="2000" b="1" dirty="0">
                 <a:solidFill>
                   <a:schemeClr val="bg1"/>
                 </a:solidFill>
               </a:rPr>
               <a:t>Contexto bajo demanda</a:t>
             </a:r>
-            <a:endParaRPr lang="en-US" sz="1800" dirty="0"/>
+            <a:endParaRPr lang="en-US" sz="2000" dirty="0"/>
           </a:p>
         </p:txBody>
       </p:sp>
@@ -9302,14 +9302,14 @@
               <a:buNone/>
             </a:pPr>
             <a:r>
-              <a:rPr lang="en-US" sz="1400" dirty="0">
+              <a:rPr lang="en-US" sz="1700" dirty="0">
                 <a:solidFill>
                   <a:schemeClr val="bg2"/>
                 </a:solidFill>
               </a:rPr>
               <a:t>1. Al inicio, el agente solo lee name y description de cada skill.</a:t>
             </a:r>
-            <a:endParaRPr lang="en-US" sz="1400" dirty="0"/>
+            <a:endParaRPr lang="en-US" sz="1700" dirty="0"/>
           </a:p>
           <a:p>
             <a:pPr indent="0" marL="0">
@@ -9318,7 +9318,7 @@
               </a:spcAft>
               <a:buNone/>
             </a:pPr>
-            <a:endParaRPr lang="en-US" sz="1400" dirty="0"/>
+            <a:endParaRPr lang="en-US" sz="1700" dirty="0"/>
           </a:p>
           <a:p>
             <a:pPr indent="0" marL="0">
@@ -9328,14 +9328,14 @@
               <a:buNone/>
             </a:pPr>
             <a:r>
-              <a:rPr lang="en-US" sz="1400" dirty="0">
+              <a:rPr lang="en-US" sz="1700" dirty="0">
                 <a:solidFill>
                   <a:schemeClr val="bg2"/>
                 </a:solidFill>
               </a:rPr>
               <a:t>2. Si tu pedido encaja con una descripción, carga el SKILL.md completo.</a:t>
             </a:r>
-            <a:endParaRPr lang="en-US" sz="1400" dirty="0"/>
+            <a:endParaRPr lang="en-US" sz="1700" dirty="0"/>
           </a:p>
           <a:p>
             <a:pPr indent="0" marL="0">
@@ -9344,7 +9344,7 @@
               </a:spcAft>
               <a:buNone/>
             </a:pPr>
-            <a:endParaRPr lang="en-US" sz="1400" dirty="0"/>
+            <a:endParaRPr lang="en-US" sz="1700" dirty="0"/>
           </a:p>
           <a:p>
             <a:pPr indent="0" marL="0">
@@ -9354,14 +9354,14 @@
               <a:buNone/>
             </a:pPr>
             <a:r>
-              <a:rPr lang="en-US" sz="1400" dirty="0">
+              <a:rPr lang="en-US" sz="1700" dirty="0">
                 <a:solidFill>
                   <a:schemeClr val="bg2"/>
                 </a:solidFill>
               </a:rPr>
               <a:t>3. Solo entonces lee los archivos que referencia.</a:t>
             </a:r>
-            <a:endParaRPr lang="en-US" sz="1400" dirty="0"/>
+            <a:endParaRPr lang="en-US" sz="1700" dirty="0"/>
           </a:p>
           <a:p>
             <a:pPr indent="0" marL="0">
@@ -9370,7 +9370,7 @@
               </a:spcAft>
               <a:buNone/>
             </a:pPr>
-            <a:endParaRPr lang="en-US" sz="1400" dirty="0"/>
+            <a:endParaRPr lang="en-US" sz="1700" dirty="0"/>
           </a:p>
           <a:p>
             <a:pPr indent="0" marL="0">
@@ -9380,14 +9380,14 @@
               <a:buNone/>
             </a:pPr>
             <a:r>
-              <a:rPr lang="en-US" sz="1400" dirty="0">
+              <a:rPr lang="en-US" sz="1700" dirty="0">
                 <a:solidFill>
                   <a:schemeClr val="bg2"/>
                 </a:solidFill>
               </a:rPr>
               <a:t>Puedes tener cien skills instaladas sin gastar tokens. Se invocan solas o a mano con /nombre.</a:t>
             </a:r>
-            <a:endParaRPr lang="en-US" sz="1400" dirty="0"/>
+            <a:endParaRPr lang="en-US" sz="1700" dirty="0"/>
           </a:p>
         </p:txBody>
       </p:sp>
@@ -9516,14 +9516,14 @@
             </a:avLst>
           </a:prstGeom>
           <a:solidFill>
-            <a:schemeClr val="accent4">
-              <a:alpha val="28000"/>
+            <a:schemeClr val="tx2">
+              <a:alpha val="88000"/>
             </a:schemeClr>
           </a:solidFill>
           <a:ln w="9525">
             <a:solidFill>
               <a:schemeClr val="accent1">
-                <a:alpha val="45000"/>
+                <a:alpha val="35000"/>
               </a:schemeClr>
             </a:solidFill>
             <a:prstDash val="solid"/>
@@ -9608,14 +9608,14 @@
               <a:buNone/>
             </a:pPr>
             <a:r>
-              <a:rPr lang="en-US" sz="1800" b="1" dirty="0">
+              <a:rPr lang="en-US" sz="2000" b="1" dirty="0">
                 <a:solidFill>
                   <a:schemeClr val="bg1"/>
                 </a:solidFill>
               </a:rPr>
               <a:t>saludo</a:t>
             </a:r>
-            <a:endParaRPr lang="en-US" sz="1800" dirty="0"/>
+            <a:endParaRPr lang="en-US" sz="2000" dirty="0"/>
           </a:p>
         </p:txBody>
       </p:sp>
@@ -9647,14 +9647,14 @@
               <a:buNone/>
             </a:pPr>
             <a:r>
-              <a:rPr lang="en-US" sz="1400" dirty="0">
+              <a:rPr lang="en-US" sz="1700" dirty="0">
                 <a:solidFill>
                   <a:schemeClr val="bg2"/>
                 </a:solidFill>
               </a:rPr>
               <a:t>Saluda por el nombre y dice qué clase toca, leyendo clases.md. Es la de la tarea.</a:t>
             </a:r>
-            <a:endParaRPr lang="en-US" sz="1400" dirty="0"/>
+            <a:endParaRPr lang="en-US" sz="1700" dirty="0"/>
           </a:p>
         </p:txBody>
       </p:sp>
@@ -9675,14 +9675,14 @@
             </a:avLst>
           </a:prstGeom>
           <a:solidFill>
-            <a:schemeClr val="accent4">
-              <a:alpha val="28000"/>
+            <a:schemeClr val="tx2">
+              <a:alpha val="88000"/>
             </a:schemeClr>
           </a:solidFill>
           <a:ln w="9525">
             <a:solidFill>
               <a:schemeClr val="accent1">
-                <a:alpha val="45000"/>
+                <a:alpha val="35000"/>
               </a:schemeClr>
             </a:solidFill>
             <a:prstDash val="solid"/>
@@ -9767,14 +9767,14 @@
               <a:buNone/>
             </a:pPr>
             <a:r>
-              <a:rPr lang="en-US" sz="1800" b="1" dirty="0">
+              <a:rPr lang="en-US" sz="2000" b="1" dirty="0">
                 <a:solidFill>
                   <a:schemeClr val="bg1"/>
                 </a:solidFill>
               </a:rPr>
               <a:t>commit</a:t>
             </a:r>
-            <a:endParaRPr lang="en-US" sz="1800" dirty="0"/>
+            <a:endParaRPr lang="en-US" sz="2000" dirty="0"/>
           </a:p>
         </p:txBody>
       </p:sp>
@@ -9806,14 +9806,14 @@
               <a:buNone/>
             </a:pPr>
             <a:r>
-              <a:rPr lang="en-US" sz="1400" dirty="0">
+              <a:rPr lang="en-US" sz="1700" dirty="0">
                 <a:solidFill>
                   <a:schemeClr val="bg2"/>
                 </a:solidFill>
               </a:rPr>
               <a:t>Conventional Commits en español e imperativo; muestra el mensaje antes de ejecutar.</a:t>
             </a:r>
-            <a:endParaRPr lang="en-US" sz="1400" dirty="0"/>
+            <a:endParaRPr lang="en-US" sz="1700" dirty="0"/>
           </a:p>
         </p:txBody>
       </p:sp>
@@ -9834,14 +9834,14 @@
             </a:avLst>
           </a:prstGeom>
           <a:solidFill>
-            <a:schemeClr val="accent4">
-              <a:alpha val="28000"/>
+            <a:schemeClr val="tx2">
+              <a:alpha val="88000"/>
             </a:schemeClr>
           </a:solidFill>
           <a:ln w="9525">
             <a:solidFill>
               <a:schemeClr val="accent1">
-                <a:alpha val="45000"/>
+                <a:alpha val="35000"/>
               </a:schemeClr>
             </a:solidFill>
             <a:prstDash val="solid"/>
@@ -9926,14 +9926,14 @@
               <a:buNone/>
             </a:pPr>
             <a:r>
-              <a:rPr lang="en-US" sz="1800" b="1" dirty="0">
+              <a:rPr lang="en-US" sz="2000" b="1" dirty="0">
                 <a:solidFill>
                   <a:schemeClr val="bg1"/>
                 </a:solidFill>
               </a:rPr>
               <a:t>revisar-pr</a:t>
             </a:r>
-            <a:endParaRPr lang="en-US" sz="1800" dirty="0"/>
+            <a:endParaRPr lang="en-US" sz="2000" dirty="0"/>
           </a:p>
         </p:txBody>
       </p:sp>
@@ -9965,14 +9965,14 @@
               <a:buNone/>
             </a:pPr>
             <a:r>
-              <a:rPr lang="en-US" sz="1400" dirty="0">
+              <a:rPr lang="en-US" sz="1700" dirty="0">
                 <a:solidFill>
                   <a:schemeClr val="bg2"/>
                 </a:solidFill>
               </a:rPr>
               <a:t>Revisa un PR con la guía GUIA.md y señala archivo:línea.</a:t>
             </a:r>
-            <a:endParaRPr lang="en-US" sz="1400" dirty="0"/>
+            <a:endParaRPr lang="en-US" sz="1700" dirty="0"/>
           </a:p>
         </p:txBody>
       </p:sp>
@@ -9993,14 +9993,14 @@
             </a:avLst>
           </a:prstGeom>
           <a:solidFill>
-            <a:schemeClr val="accent4">
-              <a:alpha val="28000"/>
+            <a:schemeClr val="tx2">
+              <a:alpha val="88000"/>
             </a:schemeClr>
           </a:solidFill>
           <a:ln w="9525">
             <a:solidFill>
               <a:schemeClr val="accent1">
-                <a:alpha val="45000"/>
+                <a:alpha val="35000"/>
               </a:schemeClr>
             </a:solidFill>
             <a:prstDash val="solid"/>
@@ -10085,14 +10085,14 @@
               <a:buNone/>
             </a:pPr>
             <a:r>
-              <a:rPr lang="en-US" sz="1800" b="1" dirty="0">
+              <a:rPr lang="en-US" sz="2000" b="1" dirty="0">
                 <a:solidFill>
                   <a:schemeClr val="bg1"/>
                 </a:solidFill>
               </a:rPr>
               <a:t>landing-editorial</a:t>
             </a:r>
-            <a:endParaRPr lang="en-US" sz="1800" dirty="0"/>
+            <a:endParaRPr lang="en-US" sz="2000" dirty="0"/>
           </a:p>
         </p:txBody>
       </p:sp>
@@ -10124,14 +10124,14 @@
               <a:buNone/>
             </a:pPr>
             <a:r>
-              <a:rPr lang="en-US" sz="1400" dirty="0">
+              <a:rPr lang="en-US" sz="1700" dirty="0">
                 <a:solidFill>
                   <a:schemeClr val="bg2"/>
                 </a:solidFill>
               </a:rPr>
               <a:t>Adjunta en el LMS (skills.zip): landings con tokens, animaciones y scroll guiado.</a:t>
             </a:r>
-            <a:endParaRPr lang="en-US" sz="1400" dirty="0"/>
+            <a:endParaRPr lang="en-US" sz="1700" dirty="0"/>
           </a:p>
         </p:txBody>
       </p:sp>
@@ -10347,14 +10347,14 @@
             </a:avLst>
           </a:prstGeom>
           <a:solidFill>
-            <a:schemeClr val="accent4">
-              <a:alpha val="28000"/>
+            <a:schemeClr val="tx2">
+              <a:alpha val="88000"/>
             </a:schemeClr>
           </a:solidFill>
           <a:ln w="9525">
             <a:solidFill>
               <a:schemeClr val="accent1">
-                <a:alpha val="45000"/>
+                <a:alpha val="35000"/>
               </a:schemeClr>
             </a:solidFill>
             <a:prstDash val="solid"/>
@@ -10511,14 +10511,14 @@
               <a:buNone/>
             </a:pPr>
             <a:r>
-              <a:rPr lang="en-US" sz="1400" dirty="0">
+              <a:rPr lang="en-US" sz="1600" dirty="0">
                 <a:solidFill>
                   <a:schemeClr val="bg2"/>
                 </a:solidFill>
               </a:rPr>
               <a:t>VS Code, Docker y jmd; conecta un agente</a:t>
             </a:r>
-            <a:endParaRPr lang="en-US" sz="1400" dirty="0"/>
+            <a:endParaRPr lang="en-US" sz="1600" dirty="0"/>
           </a:p>
         </p:txBody>
       </p:sp>
@@ -10539,14 +10539,14 @@
             </a:avLst>
           </a:prstGeom>
           <a:solidFill>
-            <a:schemeClr val="accent4">
-              <a:alpha val="28000"/>
+            <a:schemeClr val="tx2">
+              <a:alpha val="88000"/>
             </a:schemeClr>
           </a:solidFill>
           <a:ln w="9525">
             <a:solidFill>
               <a:schemeClr val="accent1">
-                <a:alpha val="45000"/>
+                <a:alpha val="35000"/>
               </a:schemeClr>
             </a:solidFill>
             <a:prstDash val="solid"/>
@@ -10703,14 +10703,14 @@
               <a:buNone/>
             </a:pPr>
             <a:r>
-              <a:rPr lang="en-US" sz="1400" dirty="0">
+              <a:rPr lang="en-US" sz="1600" dirty="0">
                 <a:solidFill>
                   <a:schemeClr val="bg2"/>
                 </a:solidFill>
               </a:rPr>
               <a:t>EVIDENCIA.md con code --version, hello-world, jmd status y captura del agente</a:t>
             </a:r>
-            <a:endParaRPr lang="en-US" sz="1400" dirty="0"/>
+            <a:endParaRPr lang="en-US" sz="1600" dirty="0"/>
           </a:p>
         </p:txBody>
       </p:sp>
@@ -10731,14 +10731,14 @@
             </a:avLst>
           </a:prstGeom>
           <a:solidFill>
-            <a:schemeClr val="accent4">
-              <a:alpha val="28000"/>
+            <a:schemeClr val="tx2">
+              <a:alpha val="88000"/>
             </a:schemeClr>
           </a:solidFill>
           <a:ln w="9525">
             <a:solidFill>
               <a:schemeClr val="accent1">
-                <a:alpha val="45000"/>
+                <a:alpha val="35000"/>
               </a:schemeClr>
             </a:solidFill>
             <a:prstDash val="solid"/>
@@ -10895,14 +10895,14 @@
               <a:buNone/>
             </a:pPr>
             <a:r>
-              <a:rPr lang="en-US" sz="1400" dirty="0">
+              <a:rPr lang="en-US" sz="1600" dirty="0">
                 <a:solidFill>
                   <a:schemeClr val="bg2"/>
                 </a:solidFill>
               </a:rPr>
               <a:t>.claude/skills/saludo/SKILL.md</a:t>
             </a:r>
-            <a:endParaRPr lang="en-US" sz="1400" dirty="0"/>
+            <a:endParaRPr lang="en-US" sz="1600" dirty="0"/>
           </a:p>
         </p:txBody>
       </p:sp>
@@ -10923,14 +10923,14 @@
             </a:avLst>
           </a:prstGeom>
           <a:solidFill>
-            <a:schemeClr val="accent4">
-              <a:alpha val="28000"/>
+            <a:schemeClr val="tx2">
+              <a:alpha val="88000"/>
             </a:schemeClr>
           </a:solidFill>
           <a:ln w="9525">
             <a:solidFill>
               <a:schemeClr val="accent1">
-                <a:alpha val="45000"/>
+                <a:alpha val="35000"/>
               </a:schemeClr>
             </a:solidFill>
             <a:prstDash val="solid"/>
@@ -11087,14 +11087,14 @@
               <a:buNone/>
             </a:pPr>
             <a:r>
-              <a:rPr lang="en-US" sz="1400" dirty="0">
+              <a:rPr lang="en-US" sz="1600" dirty="0">
                 <a:solidFill>
                   <a:schemeClr val="bg2"/>
                 </a:solidFill>
               </a:rPr>
               <a:t>URL + commit desde el LMS o jmd submit tarea-01</a:t>
             </a:r>
-            <a:endParaRPr lang="en-US" sz="1400" dirty="0"/>
+            <a:endParaRPr lang="en-US" sz="1600" dirty="0"/>
           </a:p>
         </p:txBody>
       </p:sp>
@@ -11115,14 +11115,14 @@
             </a:avLst>
           </a:prstGeom>
           <a:solidFill>
-            <a:schemeClr val="accent4">
-              <a:alpha val="28000"/>
+            <a:schemeClr val="tx2">
+              <a:alpha val="88000"/>
             </a:schemeClr>
           </a:solidFill>
           <a:ln w="9525">
             <a:solidFill>
               <a:schemeClr val="accent1">
-                <a:alpha val="45000"/>
+                <a:alpha val="35000"/>
               </a:schemeClr>
             </a:solidFill>
             <a:prstDash val="solid"/>
@@ -11402,14 +11402,14 @@
             </a:avLst>
           </a:prstGeom>
           <a:solidFill>
-            <a:schemeClr val="accent4">
-              <a:alpha val="28000"/>
+            <a:schemeClr val="tx2">
+              <a:alpha val="88000"/>
             </a:schemeClr>
           </a:solidFill>
           <a:ln w="9525">
             <a:solidFill>
               <a:schemeClr val="accent1">
-                <a:alpha val="45000"/>
+                <a:alpha val="35000"/>
               </a:schemeClr>
             </a:solidFill>
             <a:prstDash val="solid"/>
@@ -11566,14 +11566,14 @@
               <a:buNone/>
             </a:pPr>
             <a:r>
-              <a:rPr lang="en-US" sz="1400" dirty="0">
+              <a:rPr lang="en-US" sz="1600" dirty="0">
                 <a:solidFill>
                   <a:schemeClr val="bg2"/>
                 </a:solidFill>
               </a:rPr>
               <a:t>El CLI del curso y el gateway de IA</a:t>
             </a:r>
-            <a:endParaRPr lang="en-US" sz="1400" dirty="0"/>
+            <a:endParaRPr lang="en-US" sz="1600" dirty="0"/>
           </a:p>
         </p:txBody>
       </p:sp>
@@ -11594,14 +11594,14 @@
             </a:avLst>
           </a:prstGeom>
           <a:solidFill>
-            <a:schemeClr val="accent4">
-              <a:alpha val="28000"/>
+            <a:schemeClr val="tx2">
+              <a:alpha val="88000"/>
             </a:schemeClr>
           </a:solidFill>
           <a:ln w="9525">
             <a:solidFill>
               <a:schemeClr val="accent1">
-                <a:alpha val="45000"/>
+                <a:alpha val="35000"/>
               </a:schemeClr>
             </a:solidFill>
             <a:prstDash val="solid"/>
@@ -11758,14 +11758,14 @@
               <a:buNone/>
             </a:pPr>
             <a:r>
-              <a:rPr lang="en-US" sz="1400" dirty="0">
+              <a:rPr lang="en-US" sz="1600" dirty="0">
                 <a:solidFill>
                   <a:schemeClr val="bg2"/>
                 </a:solidFill>
               </a:rPr>
               <a:t>Qué es e instalarlo</a:t>
             </a:r>
-            <a:endParaRPr lang="en-US" sz="1400" dirty="0"/>
+            <a:endParaRPr lang="en-US" sz="1600" dirty="0"/>
           </a:p>
         </p:txBody>
       </p:sp>
@@ -11786,14 +11786,14 @@
             </a:avLst>
           </a:prstGeom>
           <a:solidFill>
-            <a:schemeClr val="accent4">
-              <a:alpha val="28000"/>
+            <a:schemeClr val="tx2">
+              <a:alpha val="88000"/>
             </a:schemeClr>
           </a:solidFill>
           <a:ln w="9525">
             <a:solidFill>
               <a:schemeClr val="accent1">
-                <a:alpha val="45000"/>
+                <a:alpha val="35000"/>
               </a:schemeClr>
             </a:solidFill>
             <a:prstDash val="solid"/>
@@ -11950,14 +11950,14 @@
               <a:buNone/>
             </a:pPr>
             <a:r>
-              <a:rPr lang="en-US" sz="1400" dirty="0">
+              <a:rPr lang="en-US" sz="1600" dirty="0">
                 <a:solidFill>
                   <a:schemeClr val="bg2"/>
                 </a:solidFill>
               </a:rPr>
               <a:t>Qué es e instalarlo</a:t>
             </a:r>
-            <a:endParaRPr lang="en-US" sz="1400" dirty="0"/>
+            <a:endParaRPr lang="en-US" sz="1600" dirty="0"/>
           </a:p>
         </p:txBody>
       </p:sp>
@@ -11978,14 +11978,14 @@
             </a:avLst>
           </a:prstGeom>
           <a:solidFill>
-            <a:schemeClr val="accent4">
-              <a:alpha val="28000"/>
+            <a:schemeClr val="tx2">
+              <a:alpha val="88000"/>
             </a:schemeClr>
           </a:solidFill>
           <a:ln w="9525">
             <a:solidFill>
               <a:schemeClr val="accent1">
-                <a:alpha val="45000"/>
+                <a:alpha val="35000"/>
               </a:schemeClr>
             </a:solidFill>
             <a:prstDash val="solid"/>
@@ -12142,14 +12142,14 @@
               <a:buNone/>
             </a:pPr>
             <a:r>
-              <a:rPr lang="en-US" sz="1400" dirty="0">
+              <a:rPr lang="en-US" sz="1600" dirty="0">
                 <a:solidFill>
                   <a:schemeClr val="bg2"/>
                 </a:solidFill>
               </a:rPr>
               <a:t>El bucle con herramientas</a:t>
             </a:r>
-            <a:endParaRPr lang="en-US" sz="1400" dirty="0"/>
+            <a:endParaRPr lang="en-US" sz="1600" dirty="0"/>
           </a:p>
         </p:txBody>
       </p:sp>
@@ -12170,14 +12170,14 @@
             </a:avLst>
           </a:prstGeom>
           <a:solidFill>
-            <a:schemeClr val="accent4">
-              <a:alpha val="28000"/>
+            <a:schemeClr val="tx2">
+              <a:alpha val="88000"/>
             </a:schemeClr>
           </a:solidFill>
           <a:ln w="9525">
             <a:solidFill>
               <a:schemeClr val="accent1">
-                <a:alpha val="45000"/>
+                <a:alpha val="35000"/>
               </a:schemeClr>
             </a:solidFill>
             <a:prstDash val="solid"/>
@@ -12334,14 +12334,14 @@
               <a:buNone/>
             </a:pPr>
             <a:r>
-              <a:rPr lang="en-US" sz="1400" dirty="0">
+              <a:rPr lang="en-US" sz="1600" dirty="0">
                 <a:solidFill>
                   <a:schemeClr val="bg2"/>
                 </a:solidFill>
               </a:rPr>
               <a:t>Quién aloja y qué responde</a:t>
             </a:r>
-            <a:endParaRPr lang="en-US" sz="1400" dirty="0"/>
+            <a:endParaRPr lang="en-US" sz="1600" dirty="0"/>
           </a:p>
         </p:txBody>
       </p:sp>
@@ -12362,14 +12362,14 @@
             </a:avLst>
           </a:prstGeom>
           <a:solidFill>
-            <a:schemeClr val="accent4">
-              <a:alpha val="28000"/>
+            <a:schemeClr val="tx2">
+              <a:alpha val="88000"/>
             </a:schemeClr>
           </a:solidFill>
           <a:ln w="9525">
             <a:solidFill>
               <a:schemeClr val="accent1">
-                <a:alpha val="45000"/>
+                <a:alpha val="35000"/>
               </a:schemeClr>
             </a:solidFill>
             <a:prstDash val="solid"/>
@@ -12526,14 +12526,14 @@
               <a:buNone/>
             </a:pPr>
             <a:r>
-              <a:rPr lang="en-US" sz="1400" dirty="0">
+              <a:rPr lang="en-US" sz="1600" dirty="0">
                 <a:solidFill>
                   <a:schemeClr val="bg2"/>
                 </a:solidFill>
               </a:rPr>
               <a:t>Cómo cambia la respuesta</a:t>
             </a:r>
-            <a:endParaRPr lang="en-US" sz="1400" dirty="0"/>
+            <a:endParaRPr lang="en-US" sz="1600" dirty="0"/>
           </a:p>
         </p:txBody>
       </p:sp>
@@ -12554,14 +12554,14 @@
             </a:avLst>
           </a:prstGeom>
           <a:solidFill>
-            <a:schemeClr val="accent4">
-              <a:alpha val="28000"/>
+            <a:schemeClr val="tx2">
+              <a:alpha val="88000"/>
             </a:schemeClr>
           </a:solidFill>
           <a:ln w="9525">
             <a:solidFill>
               <a:schemeClr val="accent1">
-                <a:alpha val="45000"/>
+                <a:alpha val="35000"/>
               </a:schemeClr>
             </a:solidFill>
             <a:prstDash val="solid"/>
@@ -12718,14 +12718,14 @@
               <a:buNone/>
             </a:pPr>
             <a:r>
-              <a:rPr lang="en-US" sz="1400" dirty="0">
+              <a:rPr lang="en-US" sz="1600" dirty="0">
                 <a:solidFill>
                   <a:schemeClr val="bg2"/>
                 </a:solidFill>
               </a:rPr>
               <a:t>Gastar menos tokens</a:t>
             </a:r>
-            <a:endParaRPr lang="en-US" sz="1400" dirty="0"/>
+            <a:endParaRPr lang="en-US" sz="1600" dirty="0"/>
           </a:p>
         </p:txBody>
       </p:sp>
@@ -12746,14 +12746,14 @@
             </a:avLst>
           </a:prstGeom>
           <a:solidFill>
-            <a:schemeClr val="accent4">
-              <a:alpha val="28000"/>
+            <a:schemeClr val="tx2">
+              <a:alpha val="88000"/>
             </a:schemeClr>
           </a:solidFill>
           <a:ln w="9525">
             <a:solidFill>
               <a:schemeClr val="accent1">
-                <a:alpha val="45000"/>
+                <a:alpha val="35000"/>
               </a:schemeClr>
             </a:solidFill>
             <a:prstDash val="solid"/>
@@ -12910,14 +12910,14 @@
               <a:buNone/>
             </a:pPr>
             <a:r>
-              <a:rPr lang="en-US" sz="1400" dirty="0">
+              <a:rPr lang="en-US" sz="1600" dirty="0">
                 <a:solidFill>
                   <a:schemeClr val="bg2"/>
                 </a:solidFill>
               </a:rPr>
               <a:t>Herramientas y saber hacer</a:t>
             </a:r>
-            <a:endParaRPr lang="en-US" sz="1400" dirty="0"/>
+            <a:endParaRPr lang="en-US" sz="1600" dirty="0"/>
           </a:p>
         </p:txBody>
       </p:sp>
@@ -13054,14 +13054,14 @@
               <a:buNone/>
             </a:pPr>
             <a:r>
-              <a:rPr lang="en-US" sz="1800" i="1" dirty="0">
+              <a:rPr lang="en-US" sz="2000" i="1" dirty="0">
                 <a:solidFill>
                   <a:schemeClr val="accent1"/>
                 </a:solidFill>
               </a:rPr>
               <a:t>Un binario, sin Rust y sin permisos de administrador: el instalador comprueba el SHA-256</a:t>
             </a:r>
-            <a:endParaRPr lang="en-US" sz="1800" dirty="0"/>
+            <a:endParaRPr lang="en-US" sz="2000" dirty="0"/>
           </a:p>
         </p:txBody>
       </p:sp>
@@ -13336,14 +13336,14 @@
               <a:buNone/>
             </a:pPr>
             <a:r>
-              <a:rPr lang="en-US" sz="1400" dirty="0">
+              <a:rPr lang="en-US" sz="1600" dirty="0">
                 <a:solidFill>
                   <a:schemeClr val="bg2"/>
                 </a:solidFill>
               </a:rPr>
               <a:t>Cierra y abre la terminal para que tome el PATH. En WSL instala dentro de Ubuntu, no en Windows.</a:t>
             </a:r>
-            <a:endParaRPr lang="en-US" sz="1400" dirty="0"/>
+            <a:endParaRPr lang="en-US" sz="1600" dirty="0"/>
           </a:p>
         </p:txBody>
       </p:sp>
@@ -13538,14 +13538,14 @@
             </a:avLst>
           </a:prstGeom>
           <a:solidFill>
-            <a:schemeClr val="accent4">
-              <a:alpha val="28000"/>
+            <a:schemeClr val="tx2">
+              <a:alpha val="88000"/>
             </a:schemeClr>
           </a:solidFill>
           <a:ln w="9525">
             <a:solidFill>
               <a:schemeClr val="accent1">
-                <a:alpha val="45000"/>
+                <a:alpha val="35000"/>
               </a:schemeClr>
             </a:solidFill>
             <a:prstDash val="solid"/>
@@ -13630,14 +13630,14 @@
               <a:buNone/>
             </a:pPr>
             <a:r>
-              <a:rPr lang="en-US" sz="1800" b="1" dirty="0">
+              <a:rPr lang="en-US" sz="2000" b="1" dirty="0">
                 <a:solidFill>
                   <a:schemeClr val="bg1"/>
                 </a:solidFill>
               </a:rPr>
               <a:t>¿Qué es el gateway?</a:t>
             </a:r>
-            <a:endParaRPr lang="en-US" sz="1800" dirty="0"/>
+            <a:endParaRPr lang="en-US" sz="2000" dirty="0"/>
           </a:p>
         </p:txBody>
       </p:sp>
@@ -13669,14 +13669,14 @@
               <a:buNone/>
             </a:pPr>
             <a:r>
-              <a:rPr lang="en-US" sz="1400" dirty="0">
+              <a:rPr lang="en-US" sz="1700" dirty="0">
                 <a:solidFill>
                   <a:schemeClr val="bg2"/>
                 </a:solidFill>
               </a:rPr>
               <a:t>Servidor compatible con OpenAI y Anthropic que elige el modelo, hace fallback ante un 429 y lleva las cuotas.</a:t>
             </a:r>
-            <a:endParaRPr lang="en-US" sz="1400" dirty="0"/>
+            <a:endParaRPr lang="en-US" sz="1700" dirty="0"/>
           </a:p>
         </p:txBody>
       </p:sp>
@@ -13813,14 +13813,14 @@
               <a:buNone/>
             </a:pPr>
             <a:r>
-              <a:rPr lang="en-US" sz="1800" i="1" dirty="0">
+              <a:rPr lang="en-US" sz="2000" i="1" dirty="0">
                 <a:solidFill>
                   <a:schemeClr val="accent1"/>
                 </a:solidFill>
               </a:rPr>
               <a:t>Editor gratuito y de código abierto: arranca rápido y crece con extensiones</a:t>
             </a:r>
-            <a:endParaRPr lang="en-US" sz="1800" dirty="0"/>
+            <a:endParaRPr lang="en-US" sz="2000" dirty="0"/>
           </a:p>
         </p:txBody>
       </p:sp>
@@ -13841,14 +13841,14 @@
             </a:avLst>
           </a:prstGeom>
           <a:solidFill>
-            <a:schemeClr val="accent4">
-              <a:alpha val="28000"/>
+            <a:schemeClr val="tx2">
+              <a:alpha val="88000"/>
             </a:schemeClr>
           </a:solidFill>
           <a:ln w="9525">
             <a:solidFill>
               <a:schemeClr val="accent1">
-                <a:alpha val="45000"/>
+                <a:alpha val="35000"/>
               </a:schemeClr>
             </a:solidFill>
             <a:prstDash val="solid"/>
@@ -13933,14 +13933,14 @@
               <a:buNone/>
             </a:pPr>
             <a:r>
-              <a:rPr lang="en-US" sz="1800" b="1" dirty="0">
+              <a:rPr lang="en-US" sz="2000" b="1" dirty="0">
                 <a:solidFill>
                   <a:schemeClr val="bg1"/>
                 </a:solidFill>
               </a:rPr>
               <a:t>Terminal integrada</a:t>
             </a:r>
-            <a:endParaRPr lang="en-US" sz="1800" dirty="0"/>
+            <a:endParaRPr lang="en-US" sz="2000" dirty="0"/>
           </a:p>
         </p:txBody>
       </p:sp>
@@ -13972,14 +13972,14 @@
               <a:buNone/>
             </a:pPr>
             <a:r>
-              <a:rPr lang="en-US" sz="1400" dirty="0">
+              <a:rPr lang="en-US" sz="1700" dirty="0">
                 <a:solidFill>
                   <a:schemeClr val="bg2"/>
                 </a:solidFill>
               </a:rPr>
               <a:t>Casi todo pasa en una terminal: instalar, jmd, lanzar el agente. Ctrl+ñ (teclado español) o Ctrl+` (inglés).</a:t>
             </a:r>
-            <a:endParaRPr lang="en-US" sz="1400" dirty="0"/>
+            <a:endParaRPr lang="en-US" sz="1700" dirty="0"/>
           </a:p>
         </p:txBody>
       </p:sp>
@@ -14000,14 +14000,14 @@
             </a:avLst>
           </a:prstGeom>
           <a:solidFill>
-            <a:schemeClr val="accent4">
-              <a:alpha val="28000"/>
+            <a:schemeClr val="tx2">
+              <a:alpha val="88000"/>
             </a:schemeClr>
           </a:solidFill>
           <a:ln w="9525">
             <a:solidFill>
               <a:schemeClr val="accent1">
-                <a:alpha val="45000"/>
+                <a:alpha val="35000"/>
               </a:schemeClr>
             </a:solidFill>
             <a:prstDash val="solid"/>
@@ -14092,14 +14092,14 @@
               <a:buNone/>
             </a:pPr>
             <a:r>
-              <a:rPr lang="en-US" sz="1800" b="1" dirty="0">
+              <a:rPr lang="en-US" sz="2000" b="1" dirty="0">
                 <a:solidFill>
                   <a:schemeClr val="bg1"/>
                 </a:solidFill>
               </a:rPr>
               <a:t>Paleta de comandos</a:t>
             </a:r>
-            <a:endParaRPr lang="en-US" sz="1800" dirty="0"/>
+            <a:endParaRPr lang="en-US" sz="2000" dirty="0"/>
           </a:p>
         </p:txBody>
       </p:sp>
@@ -14131,14 +14131,14 @@
               <a:buNone/>
             </a:pPr>
             <a:r>
-              <a:rPr lang="en-US" sz="1400" dirty="0">
+              <a:rPr lang="en-US" sz="1700" dirty="0">
                 <a:solidFill>
                   <a:schemeClr val="bg2"/>
                 </a:solidFill>
               </a:rPr>
               <a:t>Ctrl+Shift+P (Cmd+Shift+P en Mac): escribe lo que quieres hacer y VS Code lo encuentra.</a:t>
             </a:r>
-            <a:endParaRPr lang="en-US" sz="1400" dirty="0"/>
+            <a:endParaRPr lang="en-US" sz="1700" dirty="0"/>
           </a:p>
         </p:txBody>
       </p:sp>
@@ -14159,14 +14159,14 @@
             </a:avLst>
           </a:prstGeom>
           <a:solidFill>
-            <a:schemeClr val="accent4">
-              <a:alpha val="28000"/>
+            <a:schemeClr val="tx2">
+              <a:alpha val="88000"/>
             </a:schemeClr>
           </a:solidFill>
           <a:ln w="9525">
             <a:solidFill>
               <a:schemeClr val="accent1">
-                <a:alpha val="45000"/>
+                <a:alpha val="35000"/>
               </a:schemeClr>
             </a:solidFill>
             <a:prstDash val="solid"/>
@@ -14251,14 +14251,14 @@
               <a:buNone/>
             </a:pPr>
             <a:r>
-              <a:rPr lang="en-US" sz="1800" b="1" dirty="0">
+              <a:rPr lang="en-US" sz="2000" b="1" dirty="0">
                 <a:solidFill>
                   <a:schemeClr val="bg1"/>
                 </a:solidFill>
               </a:rPr>
               <a:t>Explorador y Git</a:t>
             </a:r>
-            <a:endParaRPr lang="en-US" sz="1800" dirty="0"/>
+            <a:endParaRPr lang="en-US" sz="2000" dirty="0"/>
           </a:p>
         </p:txBody>
       </p:sp>
@@ -14290,14 +14290,14 @@
               <a:buNone/>
             </a:pPr>
             <a:r>
-              <a:rPr lang="en-US" sz="1400" dirty="0">
+              <a:rPr lang="en-US" sz="1700" dirty="0">
                 <a:solidFill>
                   <a:schemeClr val="bg2"/>
                 </a:solidFill>
               </a:rPr>
               <a:t>Ves en vivo los archivos que el agente crea o cambia, con su diff, antes de aceptarlos.</a:t>
             </a:r>
-            <a:endParaRPr lang="en-US" sz="1400" dirty="0"/>
+            <a:endParaRPr lang="en-US" sz="1700" dirty="0"/>
           </a:p>
         </p:txBody>
       </p:sp>
@@ -14318,14 +14318,14 @@
             </a:avLst>
           </a:prstGeom>
           <a:solidFill>
-            <a:schemeClr val="accent4">
-              <a:alpha val="28000"/>
+            <a:schemeClr val="tx2">
+              <a:alpha val="88000"/>
             </a:schemeClr>
           </a:solidFill>
           <a:ln w="9525">
             <a:solidFill>
               <a:schemeClr val="accent1">
-                <a:alpha val="45000"/>
+                <a:alpha val="35000"/>
               </a:schemeClr>
             </a:solidFill>
             <a:prstDash val="solid"/>
@@ -14512,14 +14512,14 @@
               <a:buNone/>
             </a:pPr>
             <a:r>
-              <a:rPr lang="en-US" sz="1800" i="1" dirty="0">
+              <a:rPr lang="en-US" sz="2000" i="1" dirty="0">
                 <a:solidFill>
                   <a:schemeClr val="accent1"/>
                 </a:solidFill>
               </a:rPr>
               <a:t>code.visualstudio.com/download</a:t>
             </a:r>
-            <a:endParaRPr lang="en-US" sz="1800" dirty="0"/>
+            <a:endParaRPr lang="en-US" sz="2000" dirty="0"/>
           </a:p>
         </p:txBody>
       </p:sp>
@@ -14540,14 +14540,14 @@
             </a:avLst>
           </a:prstGeom>
           <a:solidFill>
-            <a:schemeClr val="accent4">
-              <a:alpha val="28000"/>
+            <a:schemeClr val="tx2">
+              <a:alpha val="88000"/>
             </a:schemeClr>
           </a:solidFill>
           <a:ln w="9525">
             <a:solidFill>
               <a:schemeClr val="accent1">
-                <a:alpha val="45000"/>
+                <a:alpha val="35000"/>
               </a:schemeClr>
             </a:solidFill>
             <a:prstDash val="solid"/>
@@ -14632,14 +14632,14 @@
               <a:buNone/>
             </a:pPr>
             <a:r>
-              <a:rPr lang="en-US" sz="1800" b="1" dirty="0">
+              <a:rPr lang="en-US" sz="2000" b="1" dirty="0">
                 <a:solidFill>
                   <a:schemeClr val="bg1"/>
                 </a:solidFill>
               </a:rPr>
               <a:t>Windows</a:t>
             </a:r>
-            <a:endParaRPr lang="en-US" sz="1800" dirty="0"/>
+            <a:endParaRPr lang="en-US" sz="2000" dirty="0"/>
           </a:p>
         </p:txBody>
       </p:sp>
@@ -14671,14 +14671,14 @@
               <a:buNone/>
             </a:pPr>
             <a:r>
-              <a:rPr lang="en-US" sz="1400" dirty="0">
+              <a:rPr lang="en-US" sz="1700" dirty="0">
                 <a:solidFill>
                   <a:schemeClr val="bg2"/>
                 </a:solidFill>
               </a:rPr>
               <a:t>User Installer de 64 bits. Marca «Agregar al PATH». Si trabajas en WSL: extensión WSL y abre la carpeta con «WSL: Ubuntu».</a:t>
             </a:r>
-            <a:endParaRPr lang="en-US" sz="1400" dirty="0"/>
+            <a:endParaRPr lang="en-US" sz="1700" dirty="0"/>
           </a:p>
         </p:txBody>
       </p:sp>
@@ -14699,14 +14699,14 @@
             </a:avLst>
           </a:prstGeom>
           <a:solidFill>
-            <a:schemeClr val="accent4">
-              <a:alpha val="28000"/>
+            <a:schemeClr val="tx2">
+              <a:alpha val="88000"/>
             </a:schemeClr>
           </a:solidFill>
           <a:ln w="9525">
             <a:solidFill>
               <a:schemeClr val="accent1">
-                <a:alpha val="45000"/>
+                <a:alpha val="35000"/>
               </a:schemeClr>
             </a:solidFill>
             <a:prstDash val="solid"/>
@@ -14791,14 +14791,14 @@
               <a:buNone/>
             </a:pPr>
             <a:r>
-              <a:rPr lang="en-US" sz="1800" b="1" dirty="0">
+              <a:rPr lang="en-US" sz="2000" b="1" dirty="0">
                 <a:solidFill>
                   <a:schemeClr val="bg1"/>
                 </a:solidFill>
               </a:rPr>
               <a:t>macOS</a:t>
             </a:r>
-            <a:endParaRPr lang="en-US" sz="1800" dirty="0"/>
+            <a:endParaRPr lang="en-US" sz="2000" dirty="0"/>
           </a:p>
         </p:txBody>
       </p:sp>
@@ -14830,14 +14830,14 @@
               <a:buNone/>
             </a:pPr>
             <a:r>
-              <a:rPr lang="en-US" sz="1400" dirty="0">
+              <a:rPr lang="en-US" sz="1700" dirty="0">
                 <a:solidFill>
                   <a:schemeClr val="bg2"/>
                 </a:solidFill>
               </a:rPr>
               <a:t>Descarga el .zip y arrastra la app a Aplicaciones. Paleta → «Shell Command: Install 'code' command in PATH».</a:t>
             </a:r>
-            <a:endParaRPr lang="en-US" sz="1400" dirty="0"/>
+            <a:endParaRPr lang="en-US" sz="1700" dirty="0"/>
           </a:p>
         </p:txBody>
       </p:sp>
@@ -14858,14 +14858,14 @@
             </a:avLst>
           </a:prstGeom>
           <a:solidFill>
-            <a:schemeClr val="accent4">
-              <a:alpha val="28000"/>
+            <a:schemeClr val="tx2">
+              <a:alpha val="88000"/>
             </a:schemeClr>
           </a:solidFill>
           <a:ln w="9525">
             <a:solidFill>
               <a:schemeClr val="accent1">
-                <a:alpha val="45000"/>
+                <a:alpha val="35000"/>
               </a:schemeClr>
             </a:solidFill>
             <a:prstDash val="solid"/>
@@ -14950,14 +14950,14 @@
               <a:buNone/>
             </a:pPr>
             <a:r>
-              <a:rPr lang="en-US" sz="1800" b="1" dirty="0">
+              <a:rPr lang="en-US" sz="2000" b="1" dirty="0">
                 <a:solidFill>
                   <a:schemeClr val="bg1"/>
                 </a:solidFill>
               </a:rPr>
               <a:t>Linux</a:t>
             </a:r>
-            <a:endParaRPr lang="en-US" sz="1800" dirty="0"/>
+            <a:endParaRPr lang="en-US" sz="2000" dirty="0"/>
           </a:p>
         </p:txBody>
       </p:sp>
@@ -14989,14 +14989,14 @@
               <a:buNone/>
             </a:pPr>
             <a:r>
-              <a:rPr lang="en-US" sz="1400" dirty="0">
+              <a:rPr lang="en-US" sz="1700" dirty="0">
                 <a:solidFill>
                   <a:schemeClr val="bg2"/>
                 </a:solidFill>
               </a:rPr>
               <a:t>Paquete .deb o .rpm desde la web, o snap install code --classic.</a:t>
             </a:r>
-            <a:endParaRPr lang="en-US" sz="1400" dirty="0"/>
+            <a:endParaRPr lang="en-US" sz="1700" dirty="0"/>
           </a:p>
         </p:txBody>
       </p:sp>
@@ -15239,14 +15239,14 @@
               <a:buNone/>
             </a:pPr>
             <a:r>
-              <a:rPr lang="en-US" sz="1800" i="1" dirty="0">
+              <a:rPr lang="en-US" sz="2000" i="1" dirty="0">
                 <a:solidFill>
                   <a:schemeClr val="accent1"/>
                 </a:solidFill>
               </a:rPr>
               <a:t>Empaqueta una app con todo lo que necesita y la ejecuta igual en cualquier máquina</a:t>
             </a:r>
-            <a:endParaRPr lang="en-US" sz="1800" dirty="0"/>
+            <a:endParaRPr lang="en-US" sz="2000" dirty="0"/>
           </a:p>
         </p:txBody>
       </p:sp>
@@ -15267,14 +15267,14 @@
             </a:avLst>
           </a:prstGeom>
           <a:solidFill>
-            <a:schemeClr val="accent4">
-              <a:alpha val="28000"/>
+            <a:schemeClr val="tx2">
+              <a:alpha val="88000"/>
             </a:schemeClr>
           </a:solidFill>
           <a:ln w="9525">
             <a:solidFill>
               <a:schemeClr val="accent1">
-                <a:alpha val="45000"/>
+                <a:alpha val="35000"/>
               </a:schemeClr>
             </a:solidFill>
             <a:prstDash val="solid"/>
@@ -15395,14 +15395,14 @@
               <a:buNone/>
             </a:pPr>
             <a:r>
-              <a:rPr lang="en-US" sz="1400" dirty="0">
+              <a:rPr lang="en-US" sz="1600" dirty="0">
                 <a:solidFill>
                   <a:schemeClr val="bg2"/>
                 </a:solidFill>
               </a:rPr>
               <a:t>La receta</a:t>
             </a:r>
-            <a:endParaRPr lang="en-US" sz="1400" dirty="0"/>
+            <a:endParaRPr lang="en-US" sz="1600" dirty="0"/>
           </a:p>
         </p:txBody>
       </p:sp>
@@ -15448,14 +15448,14 @@
             </a:avLst>
           </a:prstGeom>
           <a:solidFill>
-            <a:schemeClr val="accent4">
-              <a:alpha val="28000"/>
+            <a:schemeClr val="tx2">
+              <a:alpha val="88000"/>
             </a:schemeClr>
           </a:solidFill>
           <a:ln w="9525">
             <a:solidFill>
               <a:schemeClr val="accent1">
-                <a:alpha val="45000"/>
+                <a:alpha val="35000"/>
               </a:schemeClr>
             </a:solidFill>
             <a:prstDash val="solid"/>
@@ -15576,14 +15576,14 @@
               <a:buNone/>
             </a:pPr>
             <a:r>
-              <a:rPr lang="en-US" sz="1400" dirty="0">
+              <a:rPr lang="en-US" sz="1600" dirty="0">
                 <a:solidFill>
                   <a:schemeClr val="bg2"/>
                 </a:solidFill>
               </a:rPr>
               <a:t>Receta cocinada, de solo lectura</a:t>
             </a:r>
-            <a:endParaRPr lang="en-US" sz="1400" dirty="0"/>
+            <a:endParaRPr lang="en-US" sz="1600" dirty="0"/>
           </a:p>
         </p:txBody>
       </p:sp>
@@ -15629,14 +15629,14 @@
             </a:avLst>
           </a:prstGeom>
           <a:solidFill>
-            <a:schemeClr val="accent4">
-              <a:alpha val="28000"/>
+            <a:schemeClr val="tx2">
+              <a:alpha val="88000"/>
             </a:schemeClr>
           </a:solidFill>
           <a:ln w="9525">
             <a:solidFill>
               <a:schemeClr val="accent1">
-                <a:alpha val="45000"/>
+                <a:alpha val="35000"/>
               </a:schemeClr>
             </a:solidFill>
             <a:prstDash val="solid"/>
@@ -15757,14 +15757,14 @@
               <a:buNone/>
             </a:pPr>
             <a:r>
-              <a:rPr lang="en-US" sz="1400" dirty="0">
+              <a:rPr lang="en-US" sz="1600" dirty="0">
                 <a:solidFill>
                   <a:schemeClr val="bg2"/>
                 </a:solidFill>
               </a:rPr>
               <a:t>La imagen en ejecución, aislada</a:t>
             </a:r>
-            <a:endParaRPr lang="en-US" sz="1400" dirty="0"/>
+            <a:endParaRPr lang="en-US" sz="1600" dirty="0"/>
           </a:p>
         </p:txBody>
       </p:sp>
@@ -15785,14 +15785,14 @@
             </a:avLst>
           </a:prstGeom>
           <a:solidFill>
-            <a:schemeClr val="accent4">
-              <a:alpha val="28000"/>
+            <a:schemeClr val="tx2">
+              <a:alpha val="88000"/>
             </a:schemeClr>
           </a:solidFill>
           <a:ln w="9525">
             <a:solidFill>
               <a:schemeClr val="accent1">
-                <a:alpha val="45000"/>
+                <a:alpha val="35000"/>
               </a:schemeClr>
             </a:solidFill>
             <a:prstDash val="solid"/>
@@ -15863,14 +15863,14 @@
             </a:avLst>
           </a:prstGeom>
           <a:solidFill>
-            <a:schemeClr val="accent4">
-              <a:alpha val="28000"/>
+            <a:schemeClr val="tx2">
+              <a:alpha val="88000"/>
             </a:schemeClr>
           </a:solidFill>
           <a:ln w="9525">
             <a:solidFill>
               <a:schemeClr val="accent1">
-                <a:alpha val="45000"/>
+                <a:alpha val="35000"/>
               </a:schemeClr>
             </a:solidFill>
             <a:prstDash val="solid"/>
@@ -15941,14 +15941,14 @@
             </a:avLst>
           </a:prstGeom>
           <a:solidFill>
-            <a:schemeClr val="accent4">
-              <a:alpha val="28000"/>
+            <a:schemeClr val="tx2">
+              <a:alpha val="88000"/>
             </a:schemeClr>
           </a:solidFill>
           <a:ln w="9525">
             <a:solidFill>
               <a:schemeClr val="accent1">
-                <a:alpha val="45000"/>
+                <a:alpha val="35000"/>
               </a:schemeClr>
             </a:solidFill>
             <a:prstDash val="solid"/>
@@ -16019,14 +16019,14 @@
             </a:avLst>
           </a:prstGeom>
           <a:solidFill>
-            <a:schemeClr val="accent4">
-              <a:alpha val="28000"/>
+            <a:schemeClr val="tx2">
+              <a:alpha val="88000"/>
             </a:schemeClr>
           </a:solidFill>
           <a:ln w="9525">
             <a:solidFill>
               <a:schemeClr val="accent1">
-                <a:alpha val="45000"/>
+                <a:alpha val="35000"/>
               </a:schemeClr>
             </a:solidFill>
             <a:prstDash val="solid"/>
@@ -16213,14 +16213,14 @@
               <a:buNone/>
             </a:pPr>
             <a:r>
-              <a:rPr lang="en-US" sz="1800" i="1" dirty="0">
+              <a:rPr lang="en-US" sz="2000" i="1" dirty="0">
                 <a:solidFill>
                   <a:schemeClr val="accent1"/>
                 </a:solidFill>
               </a:rPr>
               <a:t>En el curso: levantar el gateway con un comando y ejecutar código aislado</a:t>
             </a:r>
-            <a:endParaRPr lang="en-US" sz="1800" dirty="0"/>
+            <a:endParaRPr lang="en-US" sz="2000" dirty="0"/>
           </a:p>
         </p:txBody>
       </p:sp>
@@ -16241,14 +16241,14 @@
             </a:avLst>
           </a:prstGeom>
           <a:solidFill>
-            <a:schemeClr val="accent4">
-              <a:alpha val="28000"/>
+            <a:schemeClr val="tx2">
+              <a:alpha val="88000"/>
             </a:schemeClr>
           </a:solidFill>
           <a:ln w="9525">
             <a:solidFill>
               <a:schemeClr val="accent1">
-                <a:alpha val="45000"/>
+                <a:alpha val="35000"/>
               </a:schemeClr>
             </a:solidFill>
             <a:prstDash val="solid"/>
@@ -16333,14 +16333,14 @@
               <a:buNone/>
             </a:pPr>
             <a:r>
-              <a:rPr lang="en-US" sz="1800" b="1" dirty="0">
+              <a:rPr lang="en-US" sz="2000" b="1" dirty="0">
                 <a:solidFill>
                   <a:schemeClr val="bg1"/>
                 </a:solidFill>
               </a:rPr>
               <a:t>Windows 10/11</a:t>
             </a:r>
-            <a:endParaRPr lang="en-US" sz="1800" dirty="0"/>
+            <a:endParaRPr lang="en-US" sz="2000" dirty="0"/>
           </a:p>
         </p:txBody>
       </p:sp>
@@ -16372,14 +16372,14 @@
               <a:buNone/>
             </a:pPr>
             <a:r>
-              <a:rPr lang="en-US" sz="1400" dirty="0">
+              <a:rPr lang="en-US" sz="1700" dirty="0">
                 <a:solidFill>
                   <a:schemeClr val="bg2"/>
                 </a:solidFill>
               </a:rPr>
               <a:t>Docker Desktop con WSL 2. Si falta: wsl --install como administrador y reinicia. Activa tu Ubuntu en Settings → Resources → WSL integration.</a:t>
             </a:r>
-            <a:endParaRPr lang="en-US" sz="1400" dirty="0"/>
+            <a:endParaRPr lang="en-US" sz="1700" dirty="0"/>
           </a:p>
         </p:txBody>
       </p:sp>
@@ -16400,14 +16400,14 @@
             </a:avLst>
           </a:prstGeom>
           <a:solidFill>
-            <a:schemeClr val="accent4">
-              <a:alpha val="28000"/>
+            <a:schemeClr val="tx2">
+              <a:alpha val="88000"/>
             </a:schemeClr>
           </a:solidFill>
           <a:ln w="9525">
             <a:solidFill>
               <a:schemeClr val="accent1">
-                <a:alpha val="45000"/>
+                <a:alpha val="35000"/>
               </a:schemeClr>
             </a:solidFill>
             <a:prstDash val="solid"/>
@@ -16492,14 +16492,14 @@
               <a:buNone/>
             </a:pPr>
             <a:r>
-              <a:rPr lang="en-US" sz="1800" b="1" dirty="0">
+              <a:rPr lang="en-US" sz="2000" b="1" dirty="0">
                 <a:solidFill>
                   <a:schemeClr val="bg1"/>
                 </a:solidFill>
               </a:rPr>
               <a:t>macOS</a:t>
             </a:r>
-            <a:endParaRPr lang="en-US" sz="1800" dirty="0"/>
+            <a:endParaRPr lang="en-US" sz="2000" dirty="0"/>
           </a:p>
         </p:txBody>
       </p:sp>
@@ -16531,14 +16531,14 @@
               <a:buNone/>
             </a:pPr>
             <a:r>
-              <a:rPr lang="en-US" sz="1400" dirty="0">
+              <a:rPr lang="en-US" sz="1700" dirty="0">
                 <a:solidFill>
                   <a:schemeClr val="bg2"/>
                 </a:solidFill>
               </a:rPr>
               <a:t>Docker Desktop (Apple Silicon o Intel). Alternativas más ligeras: OrbStack o Colima.</a:t>
             </a:r>
-            <a:endParaRPr lang="en-US" sz="1400" dirty="0"/>
+            <a:endParaRPr lang="en-US" sz="1700" dirty="0"/>
           </a:p>
         </p:txBody>
       </p:sp>
@@ -16559,14 +16559,14 @@
             </a:avLst>
           </a:prstGeom>
           <a:solidFill>
-            <a:schemeClr val="accent4">
-              <a:alpha val="28000"/>
+            <a:schemeClr val="tx2">
+              <a:alpha val="88000"/>
             </a:schemeClr>
           </a:solidFill>
           <a:ln w="9525">
             <a:solidFill>
               <a:schemeClr val="accent1">
-                <a:alpha val="45000"/>
+                <a:alpha val="35000"/>
               </a:schemeClr>
             </a:solidFill>
             <a:prstDash val="solid"/>
@@ -16651,14 +16651,14 @@
               <a:buNone/>
             </a:pPr>
             <a:r>
-              <a:rPr lang="en-US" sz="1800" b="1" dirty="0">
+              <a:rPr lang="en-US" sz="2000" b="1" dirty="0">
                 <a:solidFill>
                   <a:schemeClr val="bg1"/>
                 </a:solidFill>
               </a:rPr>
               <a:t>Linux</a:t>
             </a:r>
-            <a:endParaRPr lang="en-US" sz="1800" dirty="0"/>
+            <a:endParaRPr lang="en-US" sz="2000" dirty="0"/>
           </a:p>
         </p:txBody>
       </p:sp>
@@ -16690,14 +16690,14 @@
               <a:buNone/>
             </a:pPr>
             <a:r>
-              <a:rPr lang="en-US" sz="1400" dirty="0">
+              <a:rPr lang="en-US" sz="1700" dirty="0">
                 <a:solidFill>
                   <a:schemeClr val="bg2"/>
                 </a:solidFill>
               </a:rPr>
               <a:t>Docker Engine (docs.docker.com/engine/install) y luego sudo usermod -aG docker $USER. Vuelve a entrar en la sesión.</a:t>
             </a:r>
-            <a:endParaRPr lang="en-US" sz="1400" dirty="0"/>
+            <a:endParaRPr lang="en-US" sz="1700" dirty="0"/>
           </a:p>
         </p:txBody>
       </p:sp>
@@ -16832,14 +16832,14 @@
               <a:buNone/>
             </a:pPr>
             <a:r>
-              <a:rPr lang="en-US" sz="1400" dirty="0">
+              <a:rPr lang="en-US" sz="1600" dirty="0">
                 <a:solidFill>
                   <a:schemeClr val="bg2"/>
                 </a:solidFill>
               </a:rPr>
               <a:t>Si imprime «Hello from Docker!», el demonio está arriba.</a:t>
             </a:r>
-            <a:endParaRPr lang="en-US" sz="1400" dirty="0"/>
+            <a:endParaRPr lang="en-US" sz="1600" dirty="0"/>
           </a:p>
         </p:txBody>
       </p:sp>
@@ -16976,14 +16976,14 @@
               <a:buNone/>
             </a:pPr>
             <a:r>
-              <a:rPr lang="en-US" sz="1800" i="1" dirty="0">
+              <a:rPr lang="en-US" sz="2000" i="1" dirty="0">
                 <a:solidFill>
                   <a:schemeClr val="accent1"/>
                 </a:solidFill>
               </a:rPr>
               <a:t>Un modelo recibe texto y devuelve texto. Un agente lo pone en un bucle con herramientas</a:t>
             </a:r>
-            <a:endParaRPr lang="en-US" sz="1800" dirty="0"/>
+            <a:endParaRPr lang="en-US" sz="2000" dirty="0"/>
           </a:p>
         </p:txBody>
       </p:sp>
@@ -17384,14 +17384,14 @@
             </a:avLst>
           </a:prstGeom>
           <a:solidFill>
-            <a:schemeClr val="accent4">
-              <a:alpha val="28000"/>
+            <a:schemeClr val="tx2">
+              <a:alpha val="88000"/>
             </a:schemeClr>
           </a:solidFill>
           <a:ln w="9525">
             <a:solidFill>
               <a:schemeClr val="accent1">
-                <a:alpha val="45000"/>
+                <a:alpha val="35000"/>
               </a:schemeClr>
             </a:solidFill>
             <a:prstDash val="solid"/>
@@ -17476,14 +17476,14 @@
               <a:buNone/>
             </a:pPr>
             <a:r>
-              <a:rPr lang="en-US" sz="1800" b="1" dirty="0">
+              <a:rPr lang="en-US" sz="2000" b="1" dirty="0">
                 <a:solidFill>
                   <a:schemeClr val="bg1"/>
                 </a:solidFill>
               </a:rPr>
               <a:t>Sus herramientas</a:t>
             </a:r>
-            <a:endParaRPr lang="en-US" sz="1800" dirty="0"/>
+            <a:endParaRPr lang="en-US" sz="2000" dirty="0"/>
           </a:p>
         </p:txBody>
       </p:sp>
@@ -17515,14 +17515,14 @@
               <a:buNone/>
             </a:pPr>
             <a:r>
-              <a:rPr lang="en-US" sz="1400" dirty="0">
+              <a:rPr lang="en-US" sz="1700" dirty="0">
                 <a:solidFill>
                   <a:schemeClr val="bg2"/>
                 </a:solidFill>
               </a:rPr>
               <a:t>Leer y escribir archivos, ejecutar comandos, buscar en el repo y las que tú añadas por MCP.</a:t>
             </a:r>
-            <a:endParaRPr lang="en-US" sz="1400" dirty="0"/>
+            <a:endParaRPr lang="en-US" sz="1700" dirty="0"/>
           </a:p>
         </p:txBody>
       </p:sp>
@@ -17543,14 +17543,14 @@
             </a:avLst>
           </a:prstGeom>
           <a:solidFill>
-            <a:schemeClr val="accent4">
-              <a:alpha val="28000"/>
+            <a:schemeClr val="tx2">
+              <a:alpha val="88000"/>
             </a:schemeClr>
           </a:solidFill>
           <a:ln w="9525">
             <a:solidFill>
               <a:schemeClr val="accent1">
-                <a:alpha val="45000"/>
+                <a:alpha val="35000"/>
               </a:schemeClr>
             </a:solidFill>
             <a:prstDash val="solid"/>
@@ -17635,14 +17635,14 @@
               <a:buNone/>
             </a:pPr>
             <a:r>
-              <a:rPr lang="en-US" sz="1800" b="1" dirty="0">
+              <a:rPr lang="en-US" sz="2000" b="1" dirty="0">
                 <a:solidFill>
                   <a:schemeClr val="bg1"/>
                 </a:solidFill>
               </a:rPr>
               <a:t>Tu trabajo cambia</a:t>
             </a:r>
-            <a:endParaRPr lang="en-US" sz="1800" dirty="0"/>
+            <a:endParaRPr lang="en-US" sz="2000" dirty="0"/>
           </a:p>
         </p:txBody>
       </p:sp>
@@ -17674,14 +17674,14 @@
               <a:buNone/>
             </a:pPr>
             <a:r>
-              <a:rPr lang="en-US" sz="1400" dirty="0">
+              <a:rPr lang="en-US" sz="1700" dirty="0">
                 <a:solidFill>
                   <a:schemeClr val="bg2"/>
                 </a:solidFill>
               </a:rPr>
               <a:t>Defines el objetivo, das contexto, revisas lo que hace y decides. Claude Code y OpenCode son agentes de programación.</a:t>
             </a:r>
-            <a:endParaRPr lang="en-US" sz="1400" dirty="0"/>
+            <a:endParaRPr lang="en-US" sz="1700" dirty="0"/>
           </a:p>
         </p:txBody>
       </p:sp>
@@ -17810,14 +17810,14 @@
             </a:avLst>
           </a:prstGeom>
           <a:solidFill>
-            <a:schemeClr val="accent4">
-              <a:alpha val="28000"/>
+            <a:schemeClr val="tx2">
+              <a:alpha val="88000"/>
             </a:schemeClr>
           </a:solidFill>
           <a:ln w="9525">
             <a:solidFill>
               <a:schemeClr val="accent1">
-                <a:alpha val="45000"/>
+                <a:alpha val="35000"/>
               </a:schemeClr>
             </a:solidFill>
             <a:prstDash val="solid"/>
@@ -17902,14 +17902,14 @@
               <a:buNone/>
             </a:pPr>
             <a:r>
-              <a:rPr lang="en-US" sz="1800" b="1" dirty="0">
+              <a:rPr lang="en-US" sz="2000" b="1" dirty="0">
                 <a:solidFill>
                   <a:schemeClr val="bg1"/>
                 </a:solidFill>
               </a:rPr>
               <a:t>Lee el diff antes de aceptar</a:t>
             </a:r>
-            <a:endParaRPr lang="en-US" sz="1800" dirty="0"/>
+            <a:endParaRPr lang="en-US" sz="2000" dirty="0"/>
           </a:p>
         </p:txBody>
       </p:sp>
@@ -17941,14 +17941,14 @@
               <a:buNone/>
             </a:pPr>
             <a:r>
-              <a:rPr lang="en-US" sz="1400" dirty="0">
+              <a:rPr lang="en-US" sz="1700" dirty="0">
                 <a:solidFill>
                   <a:schemeClr val="bg2"/>
                 </a:solidFill>
               </a:rPr>
               <a:t>El agente propone; tú decides.</a:t>
             </a:r>
-            <a:endParaRPr lang="en-US" sz="1400" dirty="0"/>
+            <a:endParaRPr lang="en-US" sz="1700" dirty="0"/>
           </a:p>
         </p:txBody>
       </p:sp>
@@ -17969,14 +17969,14 @@
             </a:avLst>
           </a:prstGeom>
           <a:solidFill>
-            <a:schemeClr val="accent4">
-              <a:alpha val="28000"/>
+            <a:schemeClr val="tx2">
+              <a:alpha val="88000"/>
             </a:schemeClr>
           </a:solidFill>
           <a:ln w="9525">
             <a:solidFill>
               <a:schemeClr val="accent1">
-                <a:alpha val="45000"/>
+                <a:alpha val="35000"/>
               </a:schemeClr>
             </a:solidFill>
             <a:prstDash val="solid"/>
@@ -18061,14 +18061,14 @@
               <a:buNone/>
             </a:pPr>
             <a:r>
-              <a:rPr lang="en-US" sz="1800" b="1" dirty="0">
+              <a:rPr lang="en-US" sz="2000" b="1" dirty="0">
                 <a:solidFill>
                   <a:schemeClr val="bg1"/>
                 </a:solidFill>
               </a:rPr>
               <a:t>Contexto claro y corto</a:t>
             </a:r>
-            <a:endParaRPr lang="en-US" sz="1800" dirty="0"/>
+            <a:endParaRPr lang="en-US" sz="2000" dirty="0"/>
           </a:p>
         </p:txBody>
       </p:sp>
@@ -18100,14 +18100,14 @@
               <a:buNone/>
             </a:pPr>
             <a:r>
-              <a:rPr lang="en-US" sz="1400" dirty="0">
+              <a:rPr lang="en-US" sz="1700" dirty="0">
                 <a:solidFill>
                   <a:schemeClr val="bg2"/>
                 </a:solidFill>
               </a:rPr>
               <a:t>Qué quieres, dónde está el código y cómo se prueba.</a:t>
             </a:r>
-            <a:endParaRPr lang="en-US" sz="1400" dirty="0"/>
+            <a:endParaRPr lang="en-US" sz="1700" dirty="0"/>
           </a:p>
         </p:txBody>
       </p:sp>
@@ -18128,14 +18128,14 @@
             </a:avLst>
           </a:prstGeom>
           <a:solidFill>
-            <a:schemeClr val="accent4">
-              <a:alpha val="28000"/>
+            <a:schemeClr val="tx2">
+              <a:alpha val="88000"/>
             </a:schemeClr>
           </a:solidFill>
           <a:ln w="9525">
             <a:solidFill>
               <a:schemeClr val="accent1">
-                <a:alpha val="45000"/>
+                <a:alpha val="35000"/>
               </a:schemeClr>
             </a:solidFill>
             <a:prstDash val="solid"/>
@@ -18220,14 +18220,14 @@
               <a:buNone/>
             </a:pPr>
             <a:r>
-              <a:rPr lang="en-US" sz="1800" b="1" dirty="0">
+              <a:rPr lang="en-US" sz="2000" b="1" dirty="0">
                 <a:solidFill>
                   <a:schemeClr val="bg1"/>
                 </a:solidFill>
               </a:rPr>
               <a:t>Trabaja en git</a:t>
             </a:r>
-            <a:endParaRPr lang="en-US" sz="1800" dirty="0"/>
+            <a:endParaRPr lang="en-US" sz="2000" dirty="0"/>
           </a:p>
         </p:txBody>
       </p:sp>
@@ -18259,14 +18259,14 @@
               <a:buNone/>
             </a:pPr>
             <a:r>
-              <a:rPr lang="en-US" sz="1400" dirty="0">
+              <a:rPr lang="en-US" sz="1700" dirty="0">
                 <a:solidFill>
                   <a:schemeClr val="bg2"/>
                 </a:solidFill>
               </a:rPr>
               <a:t>Un commit por paso: si rompe algo, vuelves atrás.</a:t>
             </a:r>
-            <a:endParaRPr lang="en-US" sz="1400" dirty="0"/>
+            <a:endParaRPr lang="en-US" sz="1700" dirty="0"/>
           </a:p>
         </p:txBody>
       </p:sp>
@@ -18287,14 +18287,14 @@
             </a:avLst>
           </a:prstGeom>
           <a:solidFill>
-            <a:schemeClr val="accent4">
-              <a:alpha val="28000"/>
+            <a:schemeClr val="tx2">
+              <a:alpha val="88000"/>
             </a:schemeClr>
           </a:solidFill>
           <a:ln w="9525">
             <a:solidFill>
               <a:schemeClr val="accent1">
-                <a:alpha val="45000"/>
+                <a:alpha val="35000"/>
               </a:schemeClr>
             </a:solidFill>
             <a:prstDash val="solid"/>
@@ -18379,14 +18379,14 @@
               <a:buNone/>
             </a:pPr>
             <a:r>
-              <a:rPr lang="en-US" sz="1800" b="1" dirty="0">
+              <a:rPr lang="en-US" sz="2000" b="1" dirty="0">
                 <a:solidFill>
                   <a:schemeClr val="bg1"/>
                 </a:solidFill>
               </a:rPr>
               <a:t>Dale cómo comprobar</a:t>
             </a:r>
-            <a:endParaRPr lang="en-US" sz="1800" dirty="0"/>
+            <a:endParaRPr lang="en-US" sz="2000" dirty="0"/>
           </a:p>
         </p:txBody>
       </p:sp>
@@ -18418,14 +18418,14 @@
               <a:buNone/>
             </a:pPr>
             <a:r>
-              <a:rPr lang="en-US" sz="1400" dirty="0">
+              <a:rPr lang="en-US" sz="1700" dirty="0">
                 <a:solidFill>
                   <a:schemeClr val="bg2"/>
                 </a:solidFill>
               </a:rPr>
               <a:t>Una prueba o un comando: si puede verificar, se equivoca menos.</a:t>
             </a:r>
-            <a:endParaRPr lang="en-US" sz="1400" dirty="0"/>
+            <a:endParaRPr lang="en-US" sz="1700" dirty="0"/>
           </a:p>
         </p:txBody>
       </p:sp>
@@ -18483,47 +18483,47 @@
 </file>
 
 <file path=ppt/theme/theme1.xml><?xml version="1.0" encoding="utf-8"?>
-<a:theme xmlns:a="http://schemas.openxmlformats.org/drawingml/2006/main" name="JMD Morado Campeón">
+<a:theme xmlns:a="http://schemas.openxmlformats.org/drawingml/2006/main" name="JMD Sobrio">
   <a:themeElements>
-    <a:clrScheme name="JMD Morado Campeón">
+    <a:clrScheme name="JMD Sobrio">
       <a:dk1>
-        <a:srgbClr val="16052E"/>
+        <a:srgbClr val="0B0A10"/>
       </a:dk1>
       <a:lt1>
-        <a:srgbClr val="F7F2FF"/>
+        <a:srgbClr val="FFFFFF"/>
       </a:lt1>
       <a:dk2>
-        <a:srgbClr val="2E0D5E"/>
+        <a:srgbClr val="1C1830"/>
       </a:dk2>
       <a:lt2>
-        <a:srgbClr val="C3B5E3"/>
+        <a:srgbClr val="DEDAEC"/>
       </a:lt2>
       <a:accent1>
-        <a:srgbClr val="C7B2FF"/>
+        <a:srgbClr val="C9C1F0"/>
       </a:accent1>
       <a:accent2>
-        <a:srgbClr val="F2C14E"/>
+        <a:srgbClr val="E2B84A"/>
       </a:accent2>
       <a:accent3>
-        <a:srgbClr val="8FB8FF"/>
+        <a:srgbClr val="9DB8F0"/>
       </a:accent3>
       <a:accent4>
-        <a:srgbClr val="6A35C9"/>
+        <a:srgbClr val="3A3170"/>
       </a:accent4>
       <a:accent5>
-        <a:srgbClr val="7FE0A8"/>
+        <a:srgbClr val="6FCF97"/>
       </a:accent5>
       <a:accent6>
-        <a:srgbClr val="FF8FA3"/>
+        <a:srgbClr val="EF7D8D"/>
       </a:accent6>
       <a:hlink>
-        <a:srgbClr val="F2C14E"/>
+        <a:srgbClr val="E2B84A"/>
       </a:hlink>
       <a:folHlink>
-        <a:srgbClr val="C7B2FF"/>
+        <a:srgbClr val="C9C1F0"/>
       </a:folHlink>
     </a:clrScheme>
-    <a:fontScheme name="JMD Morado Campeón">
+    <a:fontScheme name="JMD Sobrio">
       <a:majorFont>
         <a:latin typeface="Arial"/>
         <a:ea typeface=""/>

</xml_diff>